<commit_message>
docs: update slide 5 with dependency-driven selection and parallel early sprints
</commit_message>
<xml_diff>
--- a/docs/presentations/brownfield-modernization.pptx
+++ b/docs/presentations/brownfield-modernization.pptx
@@ -4309,7 +4309,7 @@
               </a:defRPr>
             </a:pPr>
             <a:r>
-              <a:t>• 2. Early Value: Vertical slicing delivers working, demonstratable software from Sprint 1.</a:t>
+              <a:t>• 2. Parallel Start: Dependency analysis picks unblocked epics while early sprints run setup and specs in parallel.</a:t>
             </a:r>
           </a:p>
           <a:p>
@@ -5258,7 +5258,7 @@
               </a:defRPr>
             </a:pPr>
             <a:r>
-              <a:t>Feasible Roadmapping: Early Deliverables from Sprint 1</a:t>
+              <a:t>Roadmap Sequencing &amp; Parallel Early Sprints</a:t>
             </a:r>
           </a:p>
         </p:txBody>
@@ -5294,7 +5294,7 @@
               </a:defRPr>
             </a:pPr>
             <a:r>
-              <a:t>Addressing leadership concerns on deliverable visibility and team workload allocation.</a:t>
+              <a:t>Using discovery dependencies to sequence unblocked epics while running repo setup and specs in parallel.</a:t>
             </a:r>
           </a:p>
         </p:txBody>
@@ -5333,7 +5333,7 @@
               </a:defRPr>
             </a:pPr>
             <a:r>
-              <a:t>• BOD &amp; PM Concern Addressed: Will early sprints be lost to setup with nothing to show clients?</a:t>
+              <a:t>• Dependency Mapping: /tech-doc maps legacy call graphs and data dependencies to prioritize unblocked modules.</a:t>
             </a:r>
           </a:p>
           <a:p>
@@ -5349,7 +5349,7 @@
               </a:defRPr>
             </a:pPr>
             <a:r>
-              <a:t>• Vertical Slicing Model: Reject horizontal slicing; deliver complete end-to-end capabilities every sprint.</a:t>
+              <a:t>• Specs Worth the Investment: Coding never starts on unconfirmed specs; premature coding causes severe rework.</a:t>
             </a:r>
           </a:p>
           <a:p>
@@ -5365,7 +5365,7 @@
               </a:defRPr>
             </a:pPr>
             <a:r>
-              <a:t>• Sprint 1 Deliverable: Extract pilot slice (e.g. Auth/Token Exchange) with live demoable software.</a:t>
+              <a:t>• Parallel Early Sprints: Engineering stabilizes legacy app &amp; scaffolds repos while BA deep-dives into specs.</a:t>
             </a:r>
           </a:p>
           <a:p>
@@ -5381,7 +5381,7 @@
               </a:defRPr>
             </a:pPr>
             <a:r>
-              <a:t>• Sprint 2+ Cadence: Subsequent epics strangle legacy modules with established testing pipelines.</a:t>
+              <a:t>• Execution Transition: Once repos are ready and spec is confirmed (PR gate), Dev executes TDD implementation.</a:t>
             </a:r>
           </a:p>
         </p:txBody>

</xml_diff>

<commit_message>
docs: add complexity model routing to slide 8 and dedicated token economics slide
</commit_message>
<xml_diff>
--- a/docs/presentations/brownfield-modernization.pptx
+++ b/docs/presentations/brownfield-modernization.pptx
@@ -18,6 +18,7 @@
     <p:sldId id="266" r:id="rId17"/>
     <p:sldId id="267" r:id="rId18"/>
     <p:sldId id="268" r:id="rId19"/>
+    <p:sldId id="269" r:id="rId20"/>
   </p:sldIdLst>
   <p:sldSz cx="12191695" cy="6858000" type="screen4x3"/>
   <p:notesSz cx="6858000" cy="9144000"/>
@@ -3926,7 +3927,7 @@
               </a:defRPr>
             </a:pPr>
             <a:r>
-              <a:t>STAGE 5: SHIP</a:t>
+              <a:t>TOKEN ECONOMICS &amp; GOVERNANCE</a:t>
             </a:r>
           </a:p>
         </p:txBody>
@@ -3962,7 +3963,7 @@
               </a:defRPr>
             </a:pPr>
             <a:r>
-              <a:t>Safe Integration &amp; Living Spec Archival</a:t>
+              <a:t>Token Economics: Shift-Left Investment &amp; Optimal Routing</a:t>
             </a:r>
           </a:p>
         </p:txBody>
@@ -3998,7 +3999,7 @@
               </a:defRPr>
             </a:pPr>
             <a:r>
-              <a:t>Atomic synchronization of living specifications and automated release packaging.</a:t>
+              <a:t>Preventing exponential late-phase rework costs through upfront clarity and automated model matching.</a:t>
             </a:r>
           </a:p>
         </p:txBody>
@@ -4037,7 +4038,7 @@
               </a:defRPr>
             </a:pPr>
             <a:r>
-              <a:t>• Pre-Ship Verification: Automated suite runs linting, typechecks, tests, and specs trace audits.</a:t>
+              <a:t>• High-ROI Shift-Left: Spending tokens early in discuss to clarify specs prevents cascading legacy rework.</a:t>
             </a:r>
           </a:p>
           <a:p>
@@ -4053,7 +4054,7 @@
               </a:defRPr>
             </a:pPr>
             <a:r>
-              <a:t>• Atomic Archival: specs archive automatically merges spec-delta.md into docs/specs/&lt;cap&gt;/spec.md.</a:t>
+              <a:t>• Late Ambiguity Cost Cascade: Unclear specs discovered late force massive token burn in multi-file debug cycles.</a:t>
             </a:r>
           </a:p>
           <a:p>
@@ -4069,7 +4070,7 @@
               </a:defRPr>
             </a:pPr>
             <a:r>
-              <a:t>• Safe Strangling: Modern capability goes live, legacy route is disabled, and proposal moves to archive.</a:t>
+              <a:t>• Eliminates Guesswork: Orchestrator routes tasks to exact model and reasoning tiers, ending trial-and-error retries.</a:t>
             </a:r>
           </a:p>
           <a:p>
@@ -4085,7 +4086,7 @@
               </a:defRPr>
             </a:pPr>
             <a:r>
-              <a:t>• Zero Documentation Debt: Living specs perpetually match production reality without manual updates.</a:t>
+              <a:t>• Economic Principle: 1k tokens in spec clarity saves 50k+ tokens in late rework, hallucinated fixes, and review churn.</a:t>
             </a:r>
           </a:p>
         </p:txBody>
@@ -4182,6 +4183,262 @@
               </a:defRPr>
             </a:pPr>
             <a:r>
+              <a:t>STAGE 5: SHIP</a:t>
+            </a:r>
+          </a:p>
+        </p:txBody>
+      </p:sp>
+      <p:sp>
+        <p:nvSpPr>
+          <p:cNvPr id="4" name="TextBox 3"/>
+          <p:cNvSpPr txBox="1"/>
+          <p:nvPr/>
+        </p:nvSpPr>
+        <p:spPr>
+          <a:xfrm>
+            <a:off x="731520" y="914400"/>
+            <a:ext cx="10515600" cy="731520"/>
+          </a:xfrm>
+          <a:prstGeom prst="rect">
+            <a:avLst/>
+          </a:prstGeom>
+          <a:noFill/>
+        </p:spPr>
+        <p:txBody>
+          <a:bodyPr wrap="square">
+            <a:spAutoFit/>
+          </a:bodyPr>
+          <a:lstStyle/>
+          <a:p>
+            <a:pPr>
+              <a:defRPr sz="2600" b="1">
+                <a:solidFill>
+                  <a:srgbClr val="E6EBF2"/>
+                </a:solidFill>
+                <a:latin typeface="Segoe UI"/>
+              </a:defRPr>
+            </a:pPr>
+            <a:r>
+              <a:t>Safe Integration &amp; Living Spec Archival</a:t>
+            </a:r>
+          </a:p>
+        </p:txBody>
+      </p:sp>
+      <p:sp>
+        <p:nvSpPr>
+          <p:cNvPr id="5" name="TextBox 4"/>
+          <p:cNvSpPr txBox="1"/>
+          <p:nvPr/>
+        </p:nvSpPr>
+        <p:spPr>
+          <a:xfrm>
+            <a:off x="731520" y="1645920"/>
+            <a:ext cx="10515600" cy="457200"/>
+          </a:xfrm>
+          <a:prstGeom prst="rect">
+            <a:avLst/>
+          </a:prstGeom>
+          <a:noFill/>
+        </p:spPr>
+        <p:txBody>
+          <a:bodyPr wrap="square">
+            <a:spAutoFit/>
+          </a:bodyPr>
+          <a:lstStyle/>
+          <a:p>
+            <a:pPr>
+              <a:defRPr sz="1500">
+                <a:solidFill>
+                  <a:srgbClr val="9AA6B6"/>
+                </a:solidFill>
+                <a:latin typeface="Segoe UI"/>
+              </a:defRPr>
+            </a:pPr>
+            <a:r>
+              <a:t>Atomic synchronization of living specifications and automated release packaging.</a:t>
+            </a:r>
+          </a:p>
+        </p:txBody>
+      </p:sp>
+      <p:sp>
+        <p:nvSpPr>
+          <p:cNvPr id="6" name="TextBox 5"/>
+          <p:cNvSpPr txBox="1"/>
+          <p:nvPr/>
+        </p:nvSpPr>
+        <p:spPr>
+          <a:xfrm>
+            <a:off x="731520" y="2377440"/>
+            <a:ext cx="10515600" cy="3840480"/>
+          </a:xfrm>
+          <a:prstGeom prst="rect">
+            <a:avLst/>
+          </a:prstGeom>
+          <a:noFill/>
+        </p:spPr>
+        <p:txBody>
+          <a:bodyPr wrap="square">
+            <a:spAutoFit/>
+          </a:bodyPr>
+          <a:lstStyle/>
+          <a:p>
+            <a:pPr>
+              <a:spcAft>
+                <a:spcPts val="1600"/>
+              </a:spcAft>
+              <a:defRPr sz="1600">
+                <a:solidFill>
+                  <a:srgbClr val="E6EBF2"/>
+                </a:solidFill>
+                <a:latin typeface="Segoe UI"/>
+              </a:defRPr>
+            </a:pPr>
+            <a:r>
+              <a:t>• Pre-Ship Verification: Automated suite runs linting, typechecks, tests, and specs trace audits.</a:t>
+            </a:r>
+          </a:p>
+          <a:p>
+            <a:pPr>
+              <a:spcAft>
+                <a:spcPts val="1600"/>
+              </a:spcAft>
+              <a:defRPr sz="1600">
+                <a:solidFill>
+                  <a:srgbClr val="E6EBF2"/>
+                </a:solidFill>
+                <a:latin typeface="Segoe UI"/>
+              </a:defRPr>
+            </a:pPr>
+            <a:r>
+              <a:t>• Atomic Archival: specs archive automatically merges spec-delta.md into docs/specs/&lt;cap&gt;/spec.md.</a:t>
+            </a:r>
+          </a:p>
+          <a:p>
+            <a:pPr>
+              <a:spcAft>
+                <a:spcPts val="1600"/>
+              </a:spcAft>
+              <a:defRPr sz="1600">
+                <a:solidFill>
+                  <a:srgbClr val="E6EBF2"/>
+                </a:solidFill>
+                <a:latin typeface="Segoe UI"/>
+              </a:defRPr>
+            </a:pPr>
+            <a:r>
+              <a:t>• Safe Strangling: Modern capability goes live, legacy route is disabled, and proposal moves to archive.</a:t>
+            </a:r>
+          </a:p>
+          <a:p>
+            <a:pPr>
+              <a:spcAft>
+                <a:spcPts val="1600"/>
+              </a:spcAft>
+              <a:defRPr sz="1600">
+                <a:solidFill>
+                  <a:srgbClr val="E6EBF2"/>
+                </a:solidFill>
+                <a:latin typeface="Segoe UI"/>
+              </a:defRPr>
+            </a:pPr>
+            <a:r>
+              <a:t>• Zero Documentation Debt: Living specs perpetually match production reality without manual updates.</a:t>
+            </a:r>
+          </a:p>
+        </p:txBody>
+      </p:sp>
+    </p:spTree>
+  </p:cSld>
+  <p:clrMapOvr>
+    <a:masterClrMapping/>
+  </p:clrMapOvr>
+</p:sld>
+</file>
+
+<file path=ppt/slides/slide14.xml><?xml version="1.0" encoding="utf-8"?>
+<p:sld xmlns:a="http://schemas.openxmlformats.org/drawingml/2006/main" xmlns:p="http://schemas.openxmlformats.org/presentationml/2006/main" xmlns:r="http://schemas.openxmlformats.org/officeDocument/2006/relationships">
+  <p:cSld>
+    <p:spTree>
+      <p:nvGrpSpPr>
+        <p:cNvPr id="1" name=""/>
+        <p:cNvGrpSpPr/>
+        <p:nvPr/>
+      </p:nvGrpSpPr>
+      <p:grpSpPr/>
+      <p:sp>
+        <p:nvSpPr>
+          <p:cNvPr id="2" name="Rectangle 1"/>
+          <p:cNvSpPr/>
+          <p:nvPr/>
+        </p:nvSpPr>
+        <p:spPr>
+          <a:xfrm>
+            <a:off x="0" y="0"/>
+            <a:ext cx="12191695" cy="6858000"/>
+          </a:xfrm>
+          <a:prstGeom prst="rect">
+            <a:avLst/>
+          </a:prstGeom>
+          <a:solidFill>
+            <a:srgbClr val="0F141B"/>
+          </a:solidFill>
+          <a:ln>
+            <a:noFill/>
+          </a:ln>
+        </p:spPr>
+        <p:style>
+          <a:lnRef idx="1">
+            <a:schemeClr val="accent1"/>
+          </a:lnRef>
+          <a:fillRef idx="3">
+            <a:schemeClr val="accent1"/>
+          </a:fillRef>
+          <a:effectRef idx="2">
+            <a:schemeClr val="accent1"/>
+          </a:effectRef>
+          <a:fontRef idx="minor">
+            <a:schemeClr val="lt1"/>
+          </a:fontRef>
+        </p:style>
+        <p:txBody>
+          <a:bodyPr rtlCol="0" anchor="ctr"/>
+          <a:lstStyle/>
+          <a:p>
+            <a:pPr algn="ctr"/>
+          </a:p>
+        </p:txBody>
+      </p:sp>
+      <p:sp>
+        <p:nvSpPr>
+          <p:cNvPr id="3" name="TextBox 2"/>
+          <p:cNvSpPr txBox="1"/>
+          <p:nvPr/>
+        </p:nvSpPr>
+        <p:spPr>
+          <a:xfrm>
+            <a:off x="731520" y="548640"/>
+            <a:ext cx="10515600" cy="365760"/>
+          </a:xfrm>
+          <a:prstGeom prst="rect">
+            <a:avLst/>
+          </a:prstGeom>
+          <a:noFill/>
+        </p:spPr>
+        <p:txBody>
+          <a:bodyPr wrap="square">
+            <a:spAutoFit/>
+          </a:bodyPr>
+          <a:lstStyle/>
+          <a:p>
+            <a:pPr>
+              <a:defRPr sz="1300" b="1">
+                <a:solidFill>
+                  <a:srgbClr val="7EA2FF"/>
+                </a:solidFill>
+                <a:latin typeface="Segoe UI"/>
+              </a:defRPr>
+            </a:pPr>
+            <a:r>
               <a:t>SUMMARY &amp; ACTION PLAN</a:t>
             </a:r>
           </a:p>
@@ -6026,7 +6283,7 @@
               </a:defRPr>
             </a:pPr>
             <a:r>
-              <a:t>Architectural Decomposition &amp; Workspace Isolation</a:t>
+              <a:t>Architectural Decomposition, Worktrees &amp; Model Routing</a:t>
             </a:r>
           </a:p>
         </p:txBody>
@@ -6062,7 +6319,7 @@
               </a:defRPr>
             </a:pPr>
             <a:r>
-              <a:t>Enforcing subsystem boundaries and preventing git conflicts during development.</a:t>
+              <a:t>Enforcing subsystem boundaries, isolating workspaces, and routing models by task complexity.</a:t>
             </a:r>
           </a:p>
         </p:txBody>
@@ -6149,7 +6406,7 @@
               </a:defRPr>
             </a:pPr>
             <a:r>
-              <a:t>• Parallel Development: Multiple engineers and AI subagents work concurrently without branch locking.</a:t>
+              <a:t>• Complexity-Based Model Routing: Orchestrator evaluates track difficulty to assign optimal reasoning tiers (low/med/high).</a:t>
             </a:r>
           </a:p>
         </p:txBody>

</xml_diff>

<commit_message>
docs: add 3 pillars of token optimization to slide 12
</commit_message>
<xml_diff>
--- a/docs/presentations/brownfield-modernization.pptx
+++ b/docs/presentations/brownfield-modernization.pptx
@@ -3963,7 +3963,7 @@
               </a:defRPr>
             </a:pPr>
             <a:r>
-              <a:t>Token Economics: Shift-Left Investment &amp; Optimal Routing</a:t>
+              <a:t>Token Economics: The 3 Pillars of AI Budget Optimization</a:t>
             </a:r>
           </a:p>
         </p:txBody>
@@ -3999,7 +3999,7 @@
               </a:defRPr>
             </a:pPr>
             <a:r>
-              <a:t>Preventing exponential late-phase rework costs through upfront clarity and automated model matching.</a:t>
+              <a:t>Preventing exponential late-phase rework costs through upfront clarity, automated routing, and CLI offloading.</a:t>
             </a:r>
           </a:p>
         </p:txBody>
@@ -4038,7 +4038,7 @@
               </a:defRPr>
             </a:pPr>
             <a:r>
-              <a:t>• High-ROI Shift-Left: Spending tokens early in discuss to clarify specs prevents cascading legacy rework.</a:t>
+              <a:t>• 1. Shift-Left Investment: Spending tokens early in discuss to confirm specs prevents rippling legacy rework late in development.</a:t>
             </a:r>
           </a:p>
           <a:p>
@@ -4054,7 +4054,7 @@
               </a:defRPr>
             </a:pPr>
             <a:r>
-              <a:t>• Late Ambiguity Cost Cascade: Unclear specs discovered late force massive token burn in multi-file debug cycles.</a:t>
+              <a:t>• 2. Complexity-Based Routing: Orchestration matches tracks to optimal reasoning tiers (low/med/high), ending guesswork and retry waste.</a:t>
             </a:r>
           </a:p>
           <a:p>
@@ -4070,7 +4070,7 @@
               </a:defRPr>
             </a:pPr>
             <a:r>
-              <a:t>• Eliminates Guesswork: Orchestrator routes tasks to exact model and reasoning tiers, ending trial-and-error retries.</a:t>
+              <a:t>• 3. Local CLI Offloading: Deterministic audits (specs lint/trace/hash) run via local Python (0 tokens) without context bloat.</a:t>
             </a:r>
           </a:p>
           <a:p>
@@ -4086,7 +4086,7 @@
               </a:defRPr>
             </a:pPr>
             <a:r>
-              <a:t>• Economic Principle: 1k tokens in spec clarity saves 50k+ tokens in late rework, hallucinated fixes, and review churn.</a:t>
+              <a:t>• Economic Principle: Early spec clarity, local CLI audits, and complexity routing save 50k+ tokens per epic.</a:t>
             </a:r>
           </a:p>
         </p:txBody>

</xml_diff>

<commit_message>
docs: streamline presentation to 12 slides, enlarge typography and remove generic solution slides
</commit_message>
<xml_diff>
--- a/docs/presentations/brownfield-modernization.pptx
+++ b/docs/presentations/brownfield-modernization.pptx
@@ -17,8 +17,6 @@
     <p:sldId id="265" r:id="rId16"/>
     <p:sldId id="266" r:id="rId17"/>
     <p:sldId id="267" r:id="rId18"/>
-    <p:sldId id="268" r:id="rId19"/>
-    <p:sldId id="269" r:id="rId20"/>
   </p:sldIdLst>
   <p:sldSz cx="12191695" cy="6858000" type="screen4x3"/>
   <p:notesSz cx="6858000" cy="9144000"/>
@@ -3116,7 +3114,7 @@
             <a:avLst/>
           </a:prstGeom>
           <a:solidFill>
-            <a:srgbClr val="0F141B"/>
+            <a:srgbClr val="0B0F15"/>
           </a:solidFill>
           <a:ln>
             <a:noFill/>
@@ -3167,9 +3165,9 @@
           <a:lstStyle/>
           <a:p>
             <a:pPr>
-              <a:defRPr sz="1300" b="1">
-                <a:solidFill>
-                  <a:srgbClr val="7EA2FF"/>
+              <a:defRPr sz="1400" b="1">
+                <a:solidFill>
+                  <a:srgbClr val="60A5FA"/>
                 </a:solidFill>
                 <a:latin typeface="Segoe UI"/>
               </a:defRPr>
@@ -3203,15 +3201,15 @@
           <a:lstStyle/>
           <a:p>
             <a:pPr>
-              <a:defRPr sz="2600" b="1">
-                <a:solidFill>
-                  <a:srgbClr val="E6EBF2"/>
-                </a:solidFill>
-                <a:latin typeface="Segoe UI"/>
-              </a:defRPr>
-            </a:pPr>
-            <a:r>
-              <a:t>Modernizing Brownfield Systems with Spec-Driven Development</a:t>
+              <a:defRPr sz="2800" b="1">
+                <a:solidFill>
+                  <a:srgbClr val="F1F5F9"/>
+                </a:solidFill>
+                <a:latin typeface="Segoe UI"/>
+              </a:defRPr>
+            </a:pPr>
+            <a:r>
+              <a:t>Modernizing Brownfield Systems with gin-workflow &amp; SDD</a:t>
             </a:r>
           </a:p>
         </p:txBody>
@@ -3224,8 +3222,8 @@
         </p:nvSpPr>
         <p:spPr>
           <a:xfrm>
-            <a:off x="731520" y="1645920"/>
-            <a:ext cx="10515600" cy="457200"/>
+            <a:off x="731520" y="1691640"/>
+            <a:ext cx="10515600" cy="502920"/>
           </a:xfrm>
           <a:prstGeom prst="rect">
             <a:avLst/>
@@ -3239,15 +3237,15 @@
           <a:lstStyle/>
           <a:p>
             <a:pPr>
-              <a:defRPr sz="1500">
-                <a:solidFill>
-                  <a:srgbClr val="9AA6B6"/>
-                </a:solidFill>
-                <a:latin typeface="Segoe UI"/>
-              </a:defRPr>
-            </a:pPr>
-            <a:r>
-              <a:t>An incremental, contract-first approach for engineering teams and leadership.</a:t>
+              <a:defRPr sz="1700">
+                <a:solidFill>
+                  <a:srgbClr val="94A3B8"/>
+                </a:solidFill>
+                <a:latin typeface="Segoe UI"/>
+              </a:defRPr>
+            </a:pPr>
+            <a:r>
+              <a:t>An end-to-end operational guide: from legacy discovery to incremental delivery.</a:t>
             </a:r>
           </a:p>
         </p:txBody>
@@ -3260,8 +3258,8 @@
         </p:nvSpPr>
         <p:spPr>
           <a:xfrm>
-            <a:off x="731520" y="2377440"/>
-            <a:ext cx="10515600" cy="3840480"/>
+            <a:off x="731520" y="2468880"/>
+            <a:ext cx="10515600" cy="3931920"/>
           </a:xfrm>
           <a:prstGeom prst="rect">
             <a:avLst/>
@@ -3276,49 +3274,49 @@
           <a:p>
             <a:pPr>
               <a:spcAft>
-                <a:spcPts val="1600"/>
+                <a:spcPts val="2000"/>
               </a:spcAft>
-              <a:defRPr sz="1600">
-                <a:solidFill>
-                  <a:srgbClr val="E6EBF2"/>
-                </a:solidFill>
-                <a:latin typeface="Segoe UI"/>
-              </a:defRPr>
-            </a:pPr>
-            <a:r>
-              <a:t>• Target Audience: Board of Directors, Engineering Leadership, Product Managers, and Development Teams.</a:t>
+              <a:defRPr sz="1800">
+                <a:solidFill>
+                  <a:srgbClr val="F1F5F9"/>
+                </a:solidFill>
+                <a:latin typeface="Segoe UI"/>
+              </a:defRPr>
+            </a:pPr>
+            <a:r>
+              <a:t>•  Evidence Discovery: Automated codebase analysis extracting factual architecture without guesswork.</a:t>
             </a:r>
           </a:p>
           <a:p>
             <a:pPr>
               <a:spcAft>
-                <a:spcPts val="1600"/>
+                <a:spcPts val="2000"/>
               </a:spcAft>
-              <a:defRPr sz="1600">
-                <a:solidFill>
-                  <a:srgbClr val="E6EBF2"/>
-                </a:solidFill>
-                <a:latin typeface="Segoe UI"/>
-              </a:defRPr>
-            </a:pPr>
-            <a:r>
-              <a:t>• Core Strategy: Strangler Fig Pattern backed by living requirements contracts (SDD layout).</a:t>
+              <a:defRPr sz="1800">
+                <a:solidFill>
+                  <a:srgbClr val="F1F5F9"/>
+                </a:solidFill>
+                <a:latin typeface="Segoe UI"/>
+              </a:defRPr>
+            </a:pPr>
+            <a:r>
+              <a:t>•  Contract-First SDD: Living requirements contracts (spec.md) verified through pull requests before code is written.</a:t>
             </a:r>
           </a:p>
           <a:p>
             <a:pPr>
               <a:spcAft>
-                <a:spcPts val="1600"/>
+                <a:spcPts val="2000"/>
               </a:spcAft>
-              <a:defRPr sz="1600">
-                <a:solidFill>
-                  <a:srgbClr val="E6EBF2"/>
-                </a:solidFill>
-                <a:latin typeface="Segoe UI"/>
-              </a:defRPr>
-            </a:pPr>
-            <a:r>
-              <a:t>• Execution Engine: 6 quality-gated stages with Git worktree isolation and independent code reviews.</a:t>
+              <a:defRPr sz="1800">
+                <a:solidFill>
+                  <a:srgbClr val="F1F5F9"/>
+                </a:solidFill>
+                <a:latin typeface="Segoe UI"/>
+              </a:defRPr>
+            </a:pPr>
+            <a:r>
+              <a:t>•  Gated Execution: Git worktree isolation, test-driven execution, independent review ledgers, and trace audits.</a:t>
             </a:r>
           </a:p>
         </p:txBody>
@@ -3356,7 +3354,7 @@
             <a:avLst/>
           </a:prstGeom>
           <a:solidFill>
-            <a:srgbClr val="0F141B"/>
+            <a:srgbClr val="0B0F15"/>
           </a:solidFill>
           <a:ln>
             <a:noFill/>
@@ -3407,15 +3405,15 @@
           <a:lstStyle/>
           <a:p>
             <a:pPr>
-              <a:defRPr sz="1300" b="1">
-                <a:solidFill>
-                  <a:srgbClr val="7EA2FF"/>
-                </a:solidFill>
-                <a:latin typeface="Segoe UI"/>
-              </a:defRPr>
-            </a:pPr>
-            <a:r>
-              <a:t>VERIFICATION</a:t>
+              <a:defRPr sz="1400" b="1">
+                <a:solidFill>
+                  <a:srgbClr val="60A5FA"/>
+                </a:solidFill>
+                <a:latin typeface="Segoe UI"/>
+              </a:defRPr>
+            </a:pPr>
+            <a:r>
+              <a:t>TOKEN ECONOMICS &amp; GOVERNANCE</a:t>
             </a:r>
           </a:p>
         </p:txBody>
@@ -3443,15 +3441,15 @@
           <a:lstStyle/>
           <a:p>
             <a:pPr>
-              <a:defRPr sz="2600" b="1">
-                <a:solidFill>
-                  <a:srgbClr val="E6EBF2"/>
-                </a:solidFill>
-                <a:latin typeface="Segoe UI"/>
-              </a:defRPr>
-            </a:pPr>
-            <a:r>
-              <a:t>Independent Code Review &amp; The Review Ledger</a:t>
+              <a:defRPr sz="2800" b="1">
+                <a:solidFill>
+                  <a:srgbClr val="F1F5F9"/>
+                </a:solidFill>
+                <a:latin typeface="Segoe UI"/>
+              </a:defRPr>
+            </a:pPr>
+            <a:r>
+              <a:t>Token Economics: The 3 Pillars of AI Budget Optimization</a:t>
             </a:r>
           </a:p>
         </p:txBody>
@@ -3464,8 +3462,8 @@
         </p:nvSpPr>
         <p:spPr>
           <a:xfrm>
-            <a:off x="731520" y="1645920"/>
-            <a:ext cx="10515600" cy="457200"/>
+            <a:off x="731520" y="1691640"/>
+            <a:ext cx="10515600" cy="502920"/>
           </a:xfrm>
           <a:prstGeom prst="rect">
             <a:avLst/>
@@ -3479,15 +3477,15 @@
           <a:lstStyle/>
           <a:p>
             <a:pPr>
-              <a:defRPr sz="1500">
-                <a:solidFill>
-                  <a:srgbClr val="9AA6B6"/>
-                </a:solidFill>
-                <a:latin typeface="Segoe UI"/>
-              </a:defRPr>
-            </a:pPr>
-            <a:r>
-              <a:t>Structured review findings with documented technical resolutions.</a:t>
+              <a:defRPr sz="1700">
+                <a:solidFill>
+                  <a:srgbClr val="94A3B8"/>
+                </a:solidFill>
+                <a:latin typeface="Segoe UI"/>
+              </a:defRPr>
+            </a:pPr>
+            <a:r>
+              <a:t>Preventing exponential late-phase rework costs through upfront clarity, automated routing, and CLI offloading.</a:t>
             </a:r>
           </a:p>
         </p:txBody>
@@ -3500,8 +3498,8 @@
         </p:nvSpPr>
         <p:spPr>
           <a:xfrm>
-            <a:off x="731520" y="2377440"/>
-            <a:ext cx="10515600" cy="3840480"/>
+            <a:off x="731520" y="2468880"/>
+            <a:ext cx="10515600" cy="3931920"/>
           </a:xfrm>
           <a:prstGeom prst="rect">
             <a:avLst/>
@@ -3516,65 +3514,65 @@
           <a:p>
             <a:pPr>
               <a:spcAft>
-                <a:spcPts val="1600"/>
+                <a:spcPts val="2000"/>
               </a:spcAft>
-              <a:defRPr sz="1600">
-                <a:solidFill>
-                  <a:srgbClr val="E6EBF2"/>
-                </a:solidFill>
-                <a:latin typeface="Segoe UI"/>
-              </a:defRPr>
-            </a:pPr>
-            <a:r>
-              <a:t>• Independent Evaluator: Dedicated code-reviewer agent inspects diff against rules and test coverage.</a:t>
+              <a:defRPr sz="1800">
+                <a:solidFill>
+                  <a:srgbClr val="F1F5F9"/>
+                </a:solidFill>
+                <a:latin typeface="Segoe UI"/>
+              </a:defRPr>
+            </a:pPr>
+            <a:r>
+              <a:t>•  1. Shift-Left Investment: Spending tokens early in discuss to confirm specs prevents rippling legacy rework.</a:t>
             </a:r>
           </a:p>
           <a:p>
             <a:pPr>
               <a:spcAft>
-                <a:spcPts val="1600"/>
+                <a:spcPts val="2000"/>
               </a:spcAft>
-              <a:defRPr sz="1600">
-                <a:solidFill>
-                  <a:srgbClr val="E6EBF2"/>
-                </a:solidFill>
-                <a:latin typeface="Segoe UI"/>
-              </a:defRPr>
-            </a:pPr>
-            <a:r>
-              <a:t>• Durable Ledger: Review findings recorded in .planning/reviews/&lt;bead&gt;/findings.jsonl.</a:t>
+              <a:defRPr sz="1800">
+                <a:solidFill>
+                  <a:srgbClr val="F1F5F9"/>
+                </a:solidFill>
+                <a:latin typeface="Segoe UI"/>
+              </a:defRPr>
+            </a:pPr>
+            <a:r>
+              <a:t>•  2. Complexity-Based Routing: Orchestration matches tracks to optimal reasoning tiers (low/med/high), ending trial-and-error.</a:t>
             </a:r>
           </a:p>
           <a:p>
             <a:pPr>
               <a:spcAft>
-                <a:spcPts val="1600"/>
+                <a:spcPts val="2000"/>
               </a:spcAft>
-              <a:defRPr sz="1600">
-                <a:solidFill>
-                  <a:srgbClr val="E6EBF2"/>
-                </a:solidFill>
-                <a:latin typeface="Segoe UI"/>
-              </a:defRPr>
-            </a:pPr>
-            <a:r>
-              <a:t>• Technical Resolution Protocol: Engineers must verify and record Fix, Dispute, or Defer.</a:t>
+              <a:defRPr sz="1800">
+                <a:solidFill>
+                  <a:srgbClr val="F1F5F9"/>
+                </a:solidFill>
+                <a:latin typeface="Segoe UI"/>
+              </a:defRPr>
+            </a:pPr>
+            <a:r>
+              <a:t>•  3. Local CLI Offloading: Deterministic audits (specs lint/trace/hash) run via local Python (0 tokens) without context bloat.</a:t>
             </a:r>
           </a:p>
           <a:p>
             <a:pPr>
               <a:spcAft>
-                <a:spcPts val="1600"/>
+                <a:spcPts val="2000"/>
               </a:spcAft>
-              <a:defRPr sz="1600">
-                <a:solidFill>
-                  <a:srgbClr val="E6EBF2"/>
-                </a:solidFill>
-                <a:latin typeface="Segoe UI"/>
-              </a:defRPr>
-            </a:pPr>
-            <a:r>
-              <a:t>• No Blind Acceptance: No task closes with unresolved or unaddressed review ledger items.</a:t>
+              <a:defRPr sz="1800">
+                <a:solidFill>
+                  <a:srgbClr val="F1F5F9"/>
+                </a:solidFill>
+                <a:latin typeface="Segoe UI"/>
+              </a:defRPr>
+            </a:pPr>
+            <a:r>
+              <a:t>•  Economic Principle: Early spec clarity, local CLI audits, and complexity routing save 50k+ tokens per epic.</a:t>
             </a:r>
           </a:p>
         </p:txBody>
@@ -3612,7 +3610,7 @@
             <a:avLst/>
           </a:prstGeom>
           <a:solidFill>
-            <a:srgbClr val="0F141B"/>
+            <a:srgbClr val="0B0F15"/>
           </a:solidFill>
           <a:ln>
             <a:noFill/>
@@ -3663,15 +3661,15 @@
           <a:lstStyle/>
           <a:p>
             <a:pPr>
-              <a:defRPr sz="1300" b="1">
-                <a:solidFill>
-                  <a:srgbClr val="7EA2FF"/>
-                </a:solidFill>
-                <a:latin typeface="Segoe UI"/>
-              </a:defRPr>
-            </a:pPr>
-            <a:r>
-              <a:t>QUALITY ENGINEERING</a:t>
+              <a:defRPr sz="1400" b="1">
+                <a:solidFill>
+                  <a:srgbClr val="60A5FA"/>
+                </a:solidFill>
+                <a:latin typeface="Segoe UI"/>
+              </a:defRPr>
+            </a:pPr>
+            <a:r>
+              <a:t>STAGE 5: SHIP</a:t>
             </a:r>
           </a:p>
         </p:txBody>
@@ -3699,15 +3697,15 @@
           <a:lstStyle/>
           <a:p>
             <a:pPr>
-              <a:defRPr sz="2600" b="1">
-                <a:solidFill>
-                  <a:srgbClr val="E6EBF2"/>
-                </a:solidFill>
-                <a:latin typeface="Segoe UI"/>
-              </a:defRPr>
-            </a:pPr>
-            <a:r>
-              <a:t>Focused QA: Preventing Test Overwhelm with gin-qa</a:t>
+              <a:defRPr sz="2800" b="1">
+                <a:solidFill>
+                  <a:srgbClr val="F1F5F9"/>
+                </a:solidFill>
+                <a:latin typeface="Segoe UI"/>
+              </a:defRPr>
+            </a:pPr>
+            <a:r>
+              <a:t>Safe Integration &amp; Living Spec Archival</a:t>
             </a:r>
           </a:p>
         </p:txBody>
@@ -3720,8 +3718,8 @@
         </p:nvSpPr>
         <p:spPr>
           <a:xfrm>
-            <a:off x="731520" y="1645920"/>
-            <a:ext cx="10515600" cy="457200"/>
+            <a:off x="731520" y="1691640"/>
+            <a:ext cx="10515600" cy="502920"/>
           </a:xfrm>
           <a:prstGeom prst="rect">
             <a:avLst/>
@@ -3735,15 +3733,15 @@
           <a:lstStyle/>
           <a:p>
             <a:pPr>
-              <a:defRPr sz="1500">
-                <a:solidFill>
-                  <a:srgbClr val="9AA6B6"/>
-                </a:solidFill>
-                <a:latin typeface="Segoe UI"/>
-              </a:defRPr>
-            </a:pPr>
-            <a:r>
-              <a:t>Content-hash drift detection and targeted Playwright E2E automation.</a:t>
+              <a:defRPr sz="1700">
+                <a:solidFill>
+                  <a:srgbClr val="94A3B8"/>
+                </a:solidFill>
+                <a:latin typeface="Segoe UI"/>
+              </a:defRPr>
+            </a:pPr>
+            <a:r>
+              <a:t>Atomic synchronization of living specifications and automated release packaging.</a:t>
             </a:r>
           </a:p>
         </p:txBody>
@@ -3756,8 +3754,8 @@
         </p:nvSpPr>
         <p:spPr>
           <a:xfrm>
-            <a:off x="731520" y="2377440"/>
-            <a:ext cx="10515600" cy="3840480"/>
+            <a:off x="731520" y="2468880"/>
+            <a:ext cx="10515600" cy="3931920"/>
           </a:xfrm>
           <a:prstGeom prst="rect">
             <a:avLst/>
@@ -3772,65 +3770,65 @@
           <a:p>
             <a:pPr>
               <a:spcAft>
-                <a:spcPts val="1600"/>
+                <a:spcPts val="2000"/>
               </a:spcAft>
-              <a:defRPr sz="1600">
-                <a:solidFill>
-                  <a:srgbClr val="E6EBF2"/>
-                </a:solidFill>
-                <a:latin typeface="Segoe UI"/>
-              </a:defRPr>
-            </a:pPr>
-            <a:r>
-              <a:t>• The Overwhelm Trap: Unconstrained AI generates hundreds of low-value, noisy test cases.</a:t>
+              <a:defRPr sz="1800">
+                <a:solidFill>
+                  <a:srgbClr val="F1F5F9"/>
+                </a:solidFill>
+                <a:latin typeface="Segoe UI"/>
+              </a:defRPr>
+            </a:pPr>
+            <a:r>
+              <a:t>•  Pre-Ship Verification: Automated suite runs linting, typechecks, tests, and specs trace audits.</a:t>
             </a:r>
           </a:p>
           <a:p>
             <a:pPr>
               <a:spcAft>
-                <a:spcPts val="1600"/>
+                <a:spcPts val="2000"/>
               </a:spcAft>
-              <a:defRPr sz="1600">
-                <a:solidFill>
-                  <a:srgbClr val="E6EBF2"/>
-                </a:solidFill>
-                <a:latin typeface="Segoe UI"/>
-              </a:defRPr>
-            </a:pPr>
-            <a:r>
-              <a:t>• Policy Steering (qa/guidelines.md): QA reserves E2E tests for critical user paths, offloading edge cases.</a:t>
+              <a:defRPr sz="1800">
+                <a:solidFill>
+                  <a:srgbClr val="F1F5F9"/>
+                </a:solidFill>
+                <a:latin typeface="Segoe UI"/>
+              </a:defRPr>
+            </a:pPr>
+            <a:r>
+              <a:t>•  Atomic Archival: specs archive automatically merges spec-delta.md into docs/specs/&lt;cap&gt;/spec.md.</a:t>
             </a:r>
           </a:p>
           <a:p>
             <a:pPr>
               <a:spcAft>
-                <a:spcPts val="1600"/>
+                <a:spcPts val="2000"/>
               </a:spcAft>
-              <a:defRPr sz="1600">
-                <a:solidFill>
-                  <a:srgbClr val="E6EBF2"/>
-                </a:solidFill>
-                <a:latin typeface="Segoe UI"/>
-              </a:defRPr>
-            </a:pPr>
-            <a:r>
-              <a:t>• Hash-Pinned Drift Detection: Tests store SHA hashes (REQ-ID@hash); reports only missing or stale cases.</a:t>
+              <a:defRPr sz="1800">
+                <a:solidFill>
+                  <a:srgbClr val="F1F5F9"/>
+                </a:solidFill>
+                <a:latin typeface="Segoe UI"/>
+              </a:defRPr>
+            </a:pPr>
+            <a:r>
+              <a:t>•  Safe Strangling: Modern capability goes live, legacy route is disabled, and proposal moves to archive.</a:t>
             </a:r>
           </a:p>
           <a:p>
             <a:pPr>
               <a:spcAft>
-                <a:spcPts val="1600"/>
+                <a:spcPts val="2000"/>
               </a:spcAft>
-              <a:defRPr sz="1600">
-                <a:solidFill>
-                  <a:srgbClr val="E6EBF2"/>
-                </a:solidFill>
-                <a:latin typeface="Segoe UI"/>
-              </a:defRPr>
-            </a:pPr>
-            <a:r>
-              <a:t>• Zero Duplicate Work: Existing valid tests are untouched; QA focuses only on modified requirement deltas.</a:t>
+              <a:defRPr sz="1800">
+                <a:solidFill>
+                  <a:srgbClr val="F1F5F9"/>
+                </a:solidFill>
+                <a:latin typeface="Segoe UI"/>
+              </a:defRPr>
+            </a:pPr>
+            <a:r>
+              <a:t>•  Zero Documentation Debt: Living specs perpetually match production reality without manual updates.</a:t>
             </a:r>
           </a:p>
         </p:txBody>
@@ -3868,7 +3866,7 @@
             <a:avLst/>
           </a:prstGeom>
           <a:solidFill>
-            <a:srgbClr val="0F141B"/>
+            <a:srgbClr val="0B0F15"/>
           </a:solidFill>
           <a:ln>
             <a:noFill/>
@@ -3919,15 +3917,15 @@
           <a:lstStyle/>
           <a:p>
             <a:pPr>
-              <a:defRPr sz="1300" b="1">
-                <a:solidFill>
-                  <a:srgbClr val="7EA2FF"/>
-                </a:solidFill>
-                <a:latin typeface="Segoe UI"/>
-              </a:defRPr>
-            </a:pPr>
-            <a:r>
-              <a:t>TOKEN ECONOMICS &amp; GOVERNANCE</a:t>
+              <a:defRPr sz="1400" b="1">
+                <a:solidFill>
+                  <a:srgbClr val="60A5FA"/>
+                </a:solidFill>
+                <a:latin typeface="Segoe UI"/>
+              </a:defRPr>
+            </a:pPr>
+            <a:r>
+              <a:t>SUMMARY &amp; ACTION PLAN</a:t>
             </a:r>
           </a:p>
         </p:txBody>
@@ -3955,15 +3953,15 @@
           <a:lstStyle/>
           <a:p>
             <a:pPr>
-              <a:defRPr sz="2600" b="1">
-                <a:solidFill>
-                  <a:srgbClr val="E6EBF2"/>
-                </a:solidFill>
-                <a:latin typeface="Segoe UI"/>
-              </a:defRPr>
-            </a:pPr>
-            <a:r>
-              <a:t>Token Economics: The 3 Pillars of AI Budget Optimization</a:t>
+              <a:defRPr sz="2800" b="1">
+                <a:solidFill>
+                  <a:srgbClr val="F1F5F9"/>
+                </a:solidFill>
+                <a:latin typeface="Segoe UI"/>
+              </a:defRPr>
+            </a:pPr>
+            <a:r>
+              <a:t>The Modernization Governance Blueprint</a:t>
             </a:r>
           </a:p>
         </p:txBody>
@@ -3976,8 +3974,8 @@
         </p:nvSpPr>
         <p:spPr>
           <a:xfrm>
-            <a:off x="731520" y="1645920"/>
-            <a:ext cx="10515600" cy="457200"/>
+            <a:off x="731520" y="1691640"/>
+            <a:ext cx="10515600" cy="502920"/>
           </a:xfrm>
           <a:prstGeom prst="rect">
             <a:avLst/>
@@ -3991,15 +3989,15 @@
           <a:lstStyle/>
           <a:p>
             <a:pPr>
-              <a:defRPr sz="1500">
-                <a:solidFill>
-                  <a:srgbClr val="9AA6B6"/>
-                </a:solidFill>
-                <a:latin typeface="Segoe UI"/>
-              </a:defRPr>
-            </a:pPr>
-            <a:r>
-              <a:t>Preventing exponential late-phase rework costs through upfront clarity, automated routing, and CLI offloading.</a:t>
+              <a:defRPr sz="1700">
+                <a:solidFill>
+                  <a:srgbClr val="94A3B8"/>
+                </a:solidFill>
+                <a:latin typeface="Segoe UI"/>
+              </a:defRPr>
+            </a:pPr>
+            <a:r>
+              <a:t>Controlled, verifiable delivery designed for engineering teams and leadership.</a:t>
             </a:r>
           </a:p>
         </p:txBody>
@@ -4012,8 +4010,8 @@
         </p:nvSpPr>
         <p:spPr>
           <a:xfrm>
-            <a:off x="731520" y="2377440"/>
-            <a:ext cx="10515600" cy="3840480"/>
+            <a:off x="731520" y="2468880"/>
+            <a:ext cx="10515600" cy="3931920"/>
           </a:xfrm>
           <a:prstGeom prst="rect">
             <a:avLst/>
@@ -4028,593 +4026,81 @@
           <a:p>
             <a:pPr>
               <a:spcAft>
-                <a:spcPts val="1600"/>
+                <a:spcPts val="2000"/>
               </a:spcAft>
-              <a:defRPr sz="1600">
-                <a:solidFill>
-                  <a:srgbClr val="E6EBF2"/>
-                </a:solidFill>
-                <a:latin typeface="Segoe UI"/>
-              </a:defRPr>
-            </a:pPr>
-            <a:r>
-              <a:t>• 1. Shift-Left Investment: Spending tokens early in discuss to confirm specs prevents rippling legacy rework late in development.</a:t>
+              <a:defRPr sz="1800">
+                <a:solidFill>
+                  <a:srgbClr val="F1F5F9"/>
+                </a:solidFill>
+                <a:latin typeface="Segoe UI"/>
+              </a:defRPr>
+            </a:pPr>
+            <a:r>
+              <a:t>•  1. Verifiable Specs: Deterministic EARS grammar verified via human BA pull requests.</a:t>
             </a:r>
           </a:p>
           <a:p>
             <a:pPr>
               <a:spcAft>
-                <a:spcPts val="1600"/>
+                <a:spcPts val="2000"/>
               </a:spcAft>
-              <a:defRPr sz="1600">
-                <a:solidFill>
-                  <a:srgbClr val="E6EBF2"/>
-                </a:solidFill>
-                <a:latin typeface="Segoe UI"/>
-              </a:defRPr>
-            </a:pPr>
-            <a:r>
-              <a:t>• 2. Complexity-Based Routing: Orchestration matches tracks to optimal reasoning tiers (low/med/high), ending guesswork and retry waste.</a:t>
+              <a:defRPr sz="1800">
+                <a:solidFill>
+                  <a:srgbClr val="F1F5F9"/>
+                </a:solidFill>
+                <a:latin typeface="Segoe UI"/>
+              </a:defRPr>
+            </a:pPr>
+            <a:r>
+              <a:t>•  2. Parallel Start: Dependency analysis picks unblocked epics while early sprints run setup and specs in parallel.</a:t>
             </a:r>
           </a:p>
           <a:p>
             <a:pPr>
               <a:spcAft>
-                <a:spcPts val="1600"/>
+                <a:spcPts val="2000"/>
               </a:spcAft>
-              <a:defRPr sz="1600">
-                <a:solidFill>
-                  <a:srgbClr val="E6EBF2"/>
-                </a:solidFill>
-                <a:latin typeface="Segoe UI"/>
-              </a:defRPr>
-            </a:pPr>
-            <a:r>
-              <a:t>• 3. Local CLI Offloading: Deterministic audits (specs lint/trace/hash) run via local Python (0 tokens) without context bloat.</a:t>
+              <a:defRPr sz="1800">
+                <a:solidFill>
+                  <a:srgbClr val="F1F5F9"/>
+                </a:solidFill>
+                <a:latin typeface="Segoe UI"/>
+              </a:defRPr>
+            </a:pPr>
+            <a:r>
+              <a:t>•  3. Code Parity: Bidirectional requirement traceability ensures code strictly matches contracts.</a:t>
             </a:r>
           </a:p>
           <a:p>
             <a:pPr>
               <a:spcAft>
-                <a:spcPts val="1600"/>
+                <a:spcPts val="2000"/>
               </a:spcAft>
-              <a:defRPr sz="1600">
-                <a:solidFill>
-                  <a:srgbClr val="E6EBF2"/>
-                </a:solidFill>
-                <a:latin typeface="Segoe UI"/>
-              </a:defRPr>
-            </a:pPr>
-            <a:r>
-              <a:t>• Economic Principle: Early spec clarity, local CLI audits, and complexity routing save 50k+ tokens per epic.</a:t>
-            </a:r>
-          </a:p>
-        </p:txBody>
-      </p:sp>
-    </p:spTree>
-  </p:cSld>
-  <p:clrMapOvr>
-    <a:masterClrMapping/>
-  </p:clrMapOvr>
-</p:sld>
-</file>
-
-<file path=ppt/slides/slide13.xml><?xml version="1.0" encoding="utf-8"?>
-<p:sld xmlns:a="http://schemas.openxmlformats.org/drawingml/2006/main" xmlns:p="http://schemas.openxmlformats.org/presentationml/2006/main" xmlns:r="http://schemas.openxmlformats.org/officeDocument/2006/relationships">
-  <p:cSld>
-    <p:spTree>
-      <p:nvGrpSpPr>
-        <p:cNvPr id="1" name=""/>
-        <p:cNvGrpSpPr/>
-        <p:nvPr/>
-      </p:nvGrpSpPr>
-      <p:grpSpPr/>
-      <p:sp>
-        <p:nvSpPr>
-          <p:cNvPr id="2" name="Rectangle 1"/>
-          <p:cNvSpPr/>
-          <p:nvPr/>
-        </p:nvSpPr>
-        <p:spPr>
-          <a:xfrm>
-            <a:off x="0" y="0"/>
-            <a:ext cx="12191695" cy="6858000"/>
-          </a:xfrm>
-          <a:prstGeom prst="rect">
-            <a:avLst/>
-          </a:prstGeom>
-          <a:solidFill>
-            <a:srgbClr val="0F141B"/>
-          </a:solidFill>
-          <a:ln>
-            <a:noFill/>
-          </a:ln>
-        </p:spPr>
-        <p:style>
-          <a:lnRef idx="1">
-            <a:schemeClr val="accent1"/>
-          </a:lnRef>
-          <a:fillRef idx="3">
-            <a:schemeClr val="accent1"/>
-          </a:fillRef>
-          <a:effectRef idx="2">
-            <a:schemeClr val="accent1"/>
-          </a:effectRef>
-          <a:fontRef idx="minor">
-            <a:schemeClr val="lt1"/>
-          </a:fontRef>
-        </p:style>
-        <p:txBody>
-          <a:bodyPr rtlCol="0" anchor="ctr"/>
-          <a:lstStyle/>
-          <a:p>
-            <a:pPr algn="ctr"/>
-          </a:p>
-        </p:txBody>
-      </p:sp>
-      <p:sp>
-        <p:nvSpPr>
-          <p:cNvPr id="3" name="TextBox 2"/>
-          <p:cNvSpPr txBox="1"/>
-          <p:nvPr/>
-        </p:nvSpPr>
-        <p:spPr>
-          <a:xfrm>
-            <a:off x="731520" y="548640"/>
-            <a:ext cx="10515600" cy="365760"/>
-          </a:xfrm>
-          <a:prstGeom prst="rect">
-            <a:avLst/>
-          </a:prstGeom>
-          <a:noFill/>
-        </p:spPr>
-        <p:txBody>
-          <a:bodyPr wrap="square">
-            <a:spAutoFit/>
-          </a:bodyPr>
-          <a:lstStyle/>
-          <a:p>
-            <a:pPr>
-              <a:defRPr sz="1300" b="1">
-                <a:solidFill>
-                  <a:srgbClr val="7EA2FF"/>
-                </a:solidFill>
-                <a:latin typeface="Segoe UI"/>
-              </a:defRPr>
-            </a:pPr>
-            <a:r>
-              <a:t>STAGE 5: SHIP</a:t>
-            </a:r>
-          </a:p>
-        </p:txBody>
-      </p:sp>
-      <p:sp>
-        <p:nvSpPr>
-          <p:cNvPr id="4" name="TextBox 3"/>
-          <p:cNvSpPr txBox="1"/>
-          <p:nvPr/>
-        </p:nvSpPr>
-        <p:spPr>
-          <a:xfrm>
-            <a:off x="731520" y="914400"/>
-            <a:ext cx="10515600" cy="731520"/>
-          </a:xfrm>
-          <a:prstGeom prst="rect">
-            <a:avLst/>
-          </a:prstGeom>
-          <a:noFill/>
-        </p:spPr>
-        <p:txBody>
-          <a:bodyPr wrap="square">
-            <a:spAutoFit/>
-          </a:bodyPr>
-          <a:lstStyle/>
-          <a:p>
-            <a:pPr>
-              <a:defRPr sz="2600" b="1">
-                <a:solidFill>
-                  <a:srgbClr val="E6EBF2"/>
-                </a:solidFill>
-                <a:latin typeface="Segoe UI"/>
-              </a:defRPr>
-            </a:pPr>
-            <a:r>
-              <a:t>Safe Integration &amp; Living Spec Archival</a:t>
-            </a:r>
-          </a:p>
-        </p:txBody>
-      </p:sp>
-      <p:sp>
-        <p:nvSpPr>
-          <p:cNvPr id="5" name="TextBox 4"/>
-          <p:cNvSpPr txBox="1"/>
-          <p:nvPr/>
-        </p:nvSpPr>
-        <p:spPr>
-          <a:xfrm>
-            <a:off x="731520" y="1645920"/>
-            <a:ext cx="10515600" cy="457200"/>
-          </a:xfrm>
-          <a:prstGeom prst="rect">
-            <a:avLst/>
-          </a:prstGeom>
-          <a:noFill/>
-        </p:spPr>
-        <p:txBody>
-          <a:bodyPr wrap="square">
-            <a:spAutoFit/>
-          </a:bodyPr>
-          <a:lstStyle/>
-          <a:p>
-            <a:pPr>
-              <a:defRPr sz="1500">
-                <a:solidFill>
-                  <a:srgbClr val="9AA6B6"/>
-                </a:solidFill>
-                <a:latin typeface="Segoe UI"/>
-              </a:defRPr>
-            </a:pPr>
-            <a:r>
-              <a:t>Atomic synchronization of living specifications and automated release packaging.</a:t>
-            </a:r>
-          </a:p>
-        </p:txBody>
-      </p:sp>
-      <p:sp>
-        <p:nvSpPr>
-          <p:cNvPr id="6" name="TextBox 5"/>
-          <p:cNvSpPr txBox="1"/>
-          <p:nvPr/>
-        </p:nvSpPr>
-        <p:spPr>
-          <a:xfrm>
-            <a:off x="731520" y="2377440"/>
-            <a:ext cx="10515600" cy="3840480"/>
-          </a:xfrm>
-          <a:prstGeom prst="rect">
-            <a:avLst/>
-          </a:prstGeom>
-          <a:noFill/>
-        </p:spPr>
-        <p:txBody>
-          <a:bodyPr wrap="square">
-            <a:spAutoFit/>
-          </a:bodyPr>
-          <a:lstStyle/>
+              <a:defRPr sz="1800">
+                <a:solidFill>
+                  <a:srgbClr val="F1F5F9"/>
+                </a:solidFill>
+                <a:latin typeface="Segoe UI"/>
+              </a:defRPr>
+            </a:pPr>
+            <a:r>
+              <a:t>•  4. Focused QA: Hash-pinned drift detection prevents test case bloat and focuses on high-value paths.</a:t>
+            </a:r>
+          </a:p>
           <a:p>
             <a:pPr>
               <a:spcAft>
-                <a:spcPts val="1600"/>
+                <a:spcPts val="2000"/>
               </a:spcAft>
-              <a:defRPr sz="1600">
-                <a:solidFill>
-                  <a:srgbClr val="E6EBF2"/>
-                </a:solidFill>
-                <a:latin typeface="Segoe UI"/>
-              </a:defRPr>
-            </a:pPr>
-            <a:r>
-              <a:t>• Pre-Ship Verification: Automated suite runs linting, typechecks, tests, and specs trace audits.</a:t>
-            </a:r>
-          </a:p>
-          <a:p>
-            <a:pPr>
-              <a:spcAft>
-                <a:spcPts val="1600"/>
-              </a:spcAft>
-              <a:defRPr sz="1600">
-                <a:solidFill>
-                  <a:srgbClr val="E6EBF2"/>
-                </a:solidFill>
-                <a:latin typeface="Segoe UI"/>
-              </a:defRPr>
-            </a:pPr>
-            <a:r>
-              <a:t>• Atomic Archival: specs archive automatically merges spec-delta.md into docs/specs/&lt;cap&gt;/spec.md.</a:t>
-            </a:r>
-          </a:p>
-          <a:p>
-            <a:pPr>
-              <a:spcAft>
-                <a:spcPts val="1600"/>
-              </a:spcAft>
-              <a:defRPr sz="1600">
-                <a:solidFill>
-                  <a:srgbClr val="E6EBF2"/>
-                </a:solidFill>
-                <a:latin typeface="Segoe UI"/>
-              </a:defRPr>
-            </a:pPr>
-            <a:r>
-              <a:t>• Safe Strangling: Modern capability goes live, legacy route is disabled, and proposal moves to archive.</a:t>
-            </a:r>
-          </a:p>
-          <a:p>
-            <a:pPr>
-              <a:spcAft>
-                <a:spcPts val="1600"/>
-              </a:spcAft>
-              <a:defRPr sz="1600">
-                <a:solidFill>
-                  <a:srgbClr val="E6EBF2"/>
-                </a:solidFill>
-                <a:latin typeface="Segoe UI"/>
-              </a:defRPr>
-            </a:pPr>
-            <a:r>
-              <a:t>• Zero Documentation Debt: Living specs perpetually match production reality without manual updates.</a:t>
-            </a:r>
-          </a:p>
-        </p:txBody>
-      </p:sp>
-    </p:spTree>
-  </p:cSld>
-  <p:clrMapOvr>
-    <a:masterClrMapping/>
-  </p:clrMapOvr>
-</p:sld>
-</file>
-
-<file path=ppt/slides/slide14.xml><?xml version="1.0" encoding="utf-8"?>
-<p:sld xmlns:a="http://schemas.openxmlformats.org/drawingml/2006/main" xmlns:p="http://schemas.openxmlformats.org/presentationml/2006/main" xmlns:r="http://schemas.openxmlformats.org/officeDocument/2006/relationships">
-  <p:cSld>
-    <p:spTree>
-      <p:nvGrpSpPr>
-        <p:cNvPr id="1" name=""/>
-        <p:cNvGrpSpPr/>
-        <p:nvPr/>
-      </p:nvGrpSpPr>
-      <p:grpSpPr/>
-      <p:sp>
-        <p:nvSpPr>
-          <p:cNvPr id="2" name="Rectangle 1"/>
-          <p:cNvSpPr/>
-          <p:nvPr/>
-        </p:nvSpPr>
-        <p:spPr>
-          <a:xfrm>
-            <a:off x="0" y="0"/>
-            <a:ext cx="12191695" cy="6858000"/>
-          </a:xfrm>
-          <a:prstGeom prst="rect">
-            <a:avLst/>
-          </a:prstGeom>
-          <a:solidFill>
-            <a:srgbClr val="0F141B"/>
-          </a:solidFill>
-          <a:ln>
-            <a:noFill/>
-          </a:ln>
-        </p:spPr>
-        <p:style>
-          <a:lnRef idx="1">
-            <a:schemeClr val="accent1"/>
-          </a:lnRef>
-          <a:fillRef idx="3">
-            <a:schemeClr val="accent1"/>
-          </a:fillRef>
-          <a:effectRef idx="2">
-            <a:schemeClr val="accent1"/>
-          </a:effectRef>
-          <a:fontRef idx="minor">
-            <a:schemeClr val="lt1"/>
-          </a:fontRef>
-        </p:style>
-        <p:txBody>
-          <a:bodyPr rtlCol="0" anchor="ctr"/>
-          <a:lstStyle/>
-          <a:p>
-            <a:pPr algn="ctr"/>
-          </a:p>
-        </p:txBody>
-      </p:sp>
-      <p:sp>
-        <p:nvSpPr>
-          <p:cNvPr id="3" name="TextBox 2"/>
-          <p:cNvSpPr txBox="1"/>
-          <p:nvPr/>
-        </p:nvSpPr>
-        <p:spPr>
-          <a:xfrm>
-            <a:off x="731520" y="548640"/>
-            <a:ext cx="10515600" cy="365760"/>
-          </a:xfrm>
-          <a:prstGeom prst="rect">
-            <a:avLst/>
-          </a:prstGeom>
-          <a:noFill/>
-        </p:spPr>
-        <p:txBody>
-          <a:bodyPr wrap="square">
-            <a:spAutoFit/>
-          </a:bodyPr>
-          <a:lstStyle/>
-          <a:p>
-            <a:pPr>
-              <a:defRPr sz="1300" b="1">
-                <a:solidFill>
-                  <a:srgbClr val="7EA2FF"/>
-                </a:solidFill>
-                <a:latin typeface="Segoe UI"/>
-              </a:defRPr>
-            </a:pPr>
-            <a:r>
-              <a:t>SUMMARY &amp; ACTION PLAN</a:t>
-            </a:r>
-          </a:p>
-        </p:txBody>
-      </p:sp>
-      <p:sp>
-        <p:nvSpPr>
-          <p:cNvPr id="4" name="TextBox 3"/>
-          <p:cNvSpPr txBox="1"/>
-          <p:nvPr/>
-        </p:nvSpPr>
-        <p:spPr>
-          <a:xfrm>
-            <a:off x="731520" y="914400"/>
-            <a:ext cx="10515600" cy="731520"/>
-          </a:xfrm>
-          <a:prstGeom prst="rect">
-            <a:avLst/>
-          </a:prstGeom>
-          <a:noFill/>
-        </p:spPr>
-        <p:txBody>
-          <a:bodyPr wrap="square">
-            <a:spAutoFit/>
-          </a:bodyPr>
-          <a:lstStyle/>
-          <a:p>
-            <a:pPr>
-              <a:defRPr sz="2600" b="1">
-                <a:solidFill>
-                  <a:srgbClr val="E6EBF2"/>
-                </a:solidFill>
-                <a:latin typeface="Segoe UI"/>
-              </a:defRPr>
-            </a:pPr>
-            <a:r>
-              <a:t>The Modernization Governance Blueprint</a:t>
-            </a:r>
-          </a:p>
-        </p:txBody>
-      </p:sp>
-      <p:sp>
-        <p:nvSpPr>
-          <p:cNvPr id="5" name="TextBox 4"/>
-          <p:cNvSpPr txBox="1"/>
-          <p:nvPr/>
-        </p:nvSpPr>
-        <p:spPr>
-          <a:xfrm>
-            <a:off x="731520" y="1645920"/>
-            <a:ext cx="10515600" cy="457200"/>
-          </a:xfrm>
-          <a:prstGeom prst="rect">
-            <a:avLst/>
-          </a:prstGeom>
-          <a:noFill/>
-        </p:spPr>
-        <p:txBody>
-          <a:bodyPr wrap="square">
-            <a:spAutoFit/>
-          </a:bodyPr>
-          <a:lstStyle/>
-          <a:p>
-            <a:pPr>
-              <a:defRPr sz="1500">
-                <a:solidFill>
-                  <a:srgbClr val="9AA6B6"/>
-                </a:solidFill>
-                <a:latin typeface="Segoe UI"/>
-              </a:defRPr>
-            </a:pPr>
-            <a:r>
-              <a:t>Controlled, verifiable delivery designed for engineering teams and leadership.</a:t>
-            </a:r>
-          </a:p>
-        </p:txBody>
-      </p:sp>
-      <p:sp>
-        <p:nvSpPr>
-          <p:cNvPr id="6" name="TextBox 5"/>
-          <p:cNvSpPr txBox="1"/>
-          <p:nvPr/>
-        </p:nvSpPr>
-        <p:spPr>
-          <a:xfrm>
-            <a:off x="731520" y="2377440"/>
-            <a:ext cx="10515600" cy="3840480"/>
-          </a:xfrm>
-          <a:prstGeom prst="rect">
-            <a:avLst/>
-          </a:prstGeom>
-          <a:noFill/>
-        </p:spPr>
-        <p:txBody>
-          <a:bodyPr wrap="square">
-            <a:spAutoFit/>
-          </a:bodyPr>
-          <a:lstStyle/>
-          <a:p>
-            <a:pPr>
-              <a:spcAft>
-                <a:spcPts val="1600"/>
-              </a:spcAft>
-              <a:defRPr sz="1600">
-                <a:solidFill>
-                  <a:srgbClr val="E6EBF2"/>
-                </a:solidFill>
-                <a:latin typeface="Segoe UI"/>
-              </a:defRPr>
-            </a:pPr>
-            <a:r>
-              <a:t>• 1. Verifiable Specs: Deterministic EARS grammar verified via human BA pull requests.</a:t>
-            </a:r>
-          </a:p>
-          <a:p>
-            <a:pPr>
-              <a:spcAft>
-                <a:spcPts val="1600"/>
-              </a:spcAft>
-              <a:defRPr sz="1600">
-                <a:solidFill>
-                  <a:srgbClr val="E6EBF2"/>
-                </a:solidFill>
-                <a:latin typeface="Segoe UI"/>
-              </a:defRPr>
-            </a:pPr>
-            <a:r>
-              <a:t>• 2. Parallel Start: Dependency analysis picks unblocked epics while early sprints run setup and specs in parallel.</a:t>
-            </a:r>
-          </a:p>
-          <a:p>
-            <a:pPr>
-              <a:spcAft>
-                <a:spcPts val="1600"/>
-              </a:spcAft>
-              <a:defRPr sz="1600">
-                <a:solidFill>
-                  <a:srgbClr val="E6EBF2"/>
-                </a:solidFill>
-                <a:latin typeface="Segoe UI"/>
-              </a:defRPr>
-            </a:pPr>
-            <a:r>
-              <a:t>• 3. Code Parity: Bidirectional requirement traceability ensures code strictly matches contracts.</a:t>
-            </a:r>
-          </a:p>
-          <a:p>
-            <a:pPr>
-              <a:spcAft>
-                <a:spcPts val="1600"/>
-              </a:spcAft>
-              <a:defRPr sz="1600">
-                <a:solidFill>
-                  <a:srgbClr val="E6EBF2"/>
-                </a:solidFill>
-                <a:latin typeface="Segoe UI"/>
-              </a:defRPr>
-            </a:pPr>
-            <a:r>
-              <a:t>• 4. Focused QA: Hash-pinned drift detection prevents test case bloat and focuses on high-value paths.</a:t>
-            </a:r>
-          </a:p>
-          <a:p>
-            <a:pPr>
-              <a:spcAft>
-                <a:spcPts val="1600"/>
-              </a:spcAft>
-              <a:defRPr sz="1600">
-                <a:solidFill>
-                  <a:srgbClr val="E6EBF2"/>
-                </a:solidFill>
-                <a:latin typeface="Segoe UI"/>
-              </a:defRPr>
-            </a:pPr>
-            <a:r>
-              <a:t>• Recommended Next Step: Execute a 2-week pilot sprint on a single bounded capability (e.g. Auth).</a:t>
+              <a:defRPr sz="1800">
+                <a:solidFill>
+                  <a:srgbClr val="F1F5F9"/>
+                </a:solidFill>
+                <a:latin typeface="Segoe UI"/>
+              </a:defRPr>
+            </a:pPr>
+            <a:r>
+              <a:t>•  Recommended Next Step: Execute a 2-week pilot sprint on a single bounded capability (e.g. Auth).</a:t>
             </a:r>
           </a:p>
         </p:txBody>
@@ -4652,7 +4138,7 @@
             <a:avLst/>
           </a:prstGeom>
           <a:solidFill>
-            <a:srgbClr val="0F141B"/>
+            <a:srgbClr val="0B0F15"/>
           </a:solidFill>
           <a:ln>
             <a:noFill/>
@@ -4703,15 +4189,15 @@
           <a:lstStyle/>
           <a:p>
             <a:pPr>
-              <a:defRPr sz="1300" b="1">
-                <a:solidFill>
-                  <a:srgbClr val="7EA2FF"/>
-                </a:solidFill>
-                <a:latin typeface="Segoe UI"/>
-              </a:defRPr>
-            </a:pPr>
-            <a:r>
-              <a:t>STRATEGIC CONTEXT</a:t>
+              <a:defRPr sz="1400" b="1">
+                <a:solidFill>
+                  <a:srgbClr val="60A5FA"/>
+                </a:solidFill>
+                <a:latin typeface="Segoe UI"/>
+              </a:defRPr>
+            </a:pPr>
+            <a:r>
+              <a:t>PHASE 0: DISCOVERY</a:t>
             </a:r>
           </a:p>
         </p:txBody>
@@ -4739,15 +4225,15 @@
           <a:lstStyle/>
           <a:p>
             <a:pPr>
-              <a:defRPr sz="2600" b="1">
-                <a:solidFill>
-                  <a:srgbClr val="E6EBF2"/>
-                </a:solidFill>
-                <a:latin typeface="Segoe UI"/>
-              </a:defRPr>
-            </a:pPr>
-            <a:r>
-              <a:t>The Brownfield Dilemma &amp; Modernization Strategy</a:t>
+              <a:defRPr sz="2800" b="1">
+                <a:solidFill>
+                  <a:srgbClr val="F1F5F9"/>
+                </a:solidFill>
+                <a:latin typeface="Segoe UI"/>
+              </a:defRPr>
+            </a:pPr>
+            <a:r>
+              <a:t>Automated Discovery of Legacy Codebases (/tech-doc)</a:t>
             </a:r>
           </a:p>
         </p:txBody>
@@ -4760,8 +4246,8 @@
         </p:nvSpPr>
         <p:spPr>
           <a:xfrm>
-            <a:off x="731520" y="1645920"/>
-            <a:ext cx="10515600" cy="457200"/>
+            <a:off x="731520" y="1691640"/>
+            <a:ext cx="10515600" cy="502920"/>
           </a:xfrm>
           <a:prstGeom prst="rect">
             <a:avLst/>
@@ -4775,15 +4261,15 @@
           <a:lstStyle/>
           <a:p>
             <a:pPr>
-              <a:defRPr sz="1500">
-                <a:solidFill>
-                  <a:srgbClr val="9AA6B6"/>
-                </a:solidFill>
-                <a:latin typeface="Segoe UI"/>
-              </a:defRPr>
-            </a:pPr>
-            <a:r>
-              <a:t>Replacing legacy systems incrementally without halting ongoing business delivery.</a:t>
+              <a:defRPr sz="1700">
+                <a:solidFill>
+                  <a:srgbClr val="94A3B8"/>
+                </a:solidFill>
+                <a:latin typeface="Segoe UI"/>
+              </a:defRPr>
+            </a:pPr>
+            <a:r>
+              <a:t>Extracting factual architecture and dependency baselines directly from repository evidence.</a:t>
             </a:r>
           </a:p>
         </p:txBody>
@@ -4796,8 +4282,8 @@
         </p:nvSpPr>
         <p:spPr>
           <a:xfrm>
-            <a:off x="731520" y="2377440"/>
-            <a:ext cx="10515600" cy="3840480"/>
+            <a:off x="731520" y="2468880"/>
+            <a:ext cx="10515600" cy="3931920"/>
           </a:xfrm>
           <a:prstGeom prst="rect">
             <a:avLst/>
@@ -4812,65 +4298,65 @@
           <a:p>
             <a:pPr>
               <a:spcAft>
-                <a:spcPts val="1600"/>
+                <a:spcPts val="2000"/>
               </a:spcAft>
-              <a:defRPr sz="1600">
-                <a:solidFill>
-                  <a:srgbClr val="E6EBF2"/>
-                </a:solidFill>
-                <a:latin typeface="Segoe UI"/>
-              </a:defRPr>
-            </a:pPr>
-            <a:r>
-              <a:t>• Conventional Big-Bang Rewrite: 6-12 months freeze, undocumented legacy rules missed, high failure rate.</a:t>
+              <a:defRPr sz="1800">
+                <a:solidFill>
+                  <a:srgbClr val="F1F5F9"/>
+                </a:solidFill>
+                <a:latin typeface="Segoe UI"/>
+              </a:defRPr>
+            </a:pPr>
+            <a:r>
+              <a:t>•  The Legacy Void: Lost tribal knowledge, stale wikis, and hidden database triggers.</a:t>
             </a:r>
           </a:p>
           <a:p>
             <a:pPr>
               <a:spcAft>
-                <a:spcPts val="1600"/>
+                <a:spcPts val="2000"/>
               </a:spcAft>
-              <a:defRPr sz="1600">
-                <a:solidFill>
-                  <a:srgbClr val="E6EBF2"/>
-                </a:solidFill>
-                <a:latin typeface="Segoe UI"/>
-              </a:defRPr>
-            </a:pPr>
-            <a:r>
-              <a:t>• Incremental SDD Modernization: Each sprint ships an operational, production-ready vertical slice.</a:t>
+              <a:defRPr sz="1800">
+                <a:solidFill>
+                  <a:srgbClr val="F1F5F9"/>
+                </a:solidFill>
+                <a:latin typeface="Segoe UI"/>
+              </a:defRPr>
+            </a:pPr>
+            <a:r>
+              <a:t>•  Evidence Extraction: Scans AST, routing tables, and schemas directly from checked-out source code.</a:t>
             </a:r>
           </a:p>
           <a:p>
             <a:pPr>
               <a:spcAft>
-                <a:spcPts val="1600"/>
+                <a:spcPts val="2000"/>
               </a:spcAft>
-              <a:defRPr sz="1600">
-                <a:solidFill>
-                  <a:srgbClr val="E6EBF2"/>
-                </a:solidFill>
-                <a:latin typeface="Segoe UI"/>
-              </a:defRPr>
-            </a:pPr>
-            <a:r>
-              <a:t>• Strangler Fig Routing: API facade directs traffic to modernized capabilities one by one.</a:t>
+              <a:defRPr sz="1800">
+                <a:solidFill>
+                  <a:srgbClr val="F1F5F9"/>
+                </a:solidFill>
+                <a:latin typeface="Segoe UI"/>
+              </a:defRPr>
+            </a:pPr>
+            <a:r>
+              <a:t>•  10 Structured Modules: Generates verified baseline in docs/codebase/ (ARCHITECTURE, API, STACK, STRUCTURE).</a:t>
             </a:r>
           </a:p>
           <a:p>
             <a:pPr>
               <a:spcAft>
-                <a:spcPts val="1600"/>
+                <a:spcPts val="2000"/>
               </a:spcAft>
-              <a:defRPr sz="1600">
-                <a:solidFill>
-                  <a:srgbClr val="E6EBF2"/>
-                </a:solidFill>
-                <a:latin typeface="Segoe UI"/>
-              </a:defRPr>
-            </a:pPr>
-            <a:r>
-              <a:t>• Living Contracts: Requirements codified in docs/specs/ with verifiable scenarios and regression protection.</a:t>
+              <a:defRPr sz="1800">
+                <a:solidFill>
+                  <a:srgbClr val="F1F5F9"/>
+                </a:solidFill>
+                <a:latin typeface="Segoe UI"/>
+              </a:defRPr>
+            </a:pPr>
+            <a:r>
+              <a:t>•  Zero Speculation: Every architectural finding links to exact file paths and line ranges.</a:t>
             </a:r>
           </a:p>
         </p:txBody>
@@ -4908,7 +4394,7 @@
             <a:avLst/>
           </a:prstGeom>
           <a:solidFill>
-            <a:srgbClr val="0F141B"/>
+            <a:srgbClr val="0B0F15"/>
           </a:solidFill>
           <a:ln>
             <a:noFill/>
@@ -4959,15 +4445,15 @@
           <a:lstStyle/>
           <a:p>
             <a:pPr>
-              <a:defRPr sz="1300" b="1">
-                <a:solidFill>
-                  <a:srgbClr val="7EA2FF"/>
-                </a:solidFill>
-                <a:latin typeface="Segoe UI"/>
-              </a:defRPr>
-            </a:pPr>
-            <a:r>
-              <a:t>TARGET ARCHITECTURE</a:t>
+              <a:defRPr sz="1400" b="1">
+                <a:solidFill>
+                  <a:srgbClr val="60A5FA"/>
+                </a:solidFill>
+                <a:latin typeface="Segoe UI"/>
+              </a:defRPr>
+            </a:pPr>
+            <a:r>
+              <a:t>ROADMAP GOVERNANCE</a:t>
             </a:r>
           </a:p>
         </p:txBody>
@@ -4995,15 +4481,15 @@
           <a:lstStyle/>
           <a:p>
             <a:pPr>
-              <a:defRPr sz="2600" b="1">
-                <a:solidFill>
-                  <a:srgbClr val="E6EBF2"/>
-                </a:solidFill>
-                <a:latin typeface="Segoe UI"/>
-              </a:defRPr>
-            </a:pPr>
-            <a:r>
-              <a:t>Strangler Fig Architecture with Facade Routing</a:t>
+              <a:defRPr sz="2800" b="1">
+                <a:solidFill>
+                  <a:srgbClr val="F1F5F9"/>
+                </a:solidFill>
+                <a:latin typeface="Segoe UI"/>
+              </a:defRPr>
+            </a:pPr>
+            <a:r>
+              <a:t>Roadmap Sequencing &amp; Parallel Early Sprints</a:t>
             </a:r>
           </a:p>
         </p:txBody>
@@ -5016,8 +4502,8 @@
         </p:nvSpPr>
         <p:spPr>
           <a:xfrm>
-            <a:off x="731520" y="1645920"/>
-            <a:ext cx="10515600" cy="457200"/>
+            <a:off x="731520" y="1691640"/>
+            <a:ext cx="10515600" cy="502920"/>
           </a:xfrm>
           <a:prstGeom prst="rect">
             <a:avLst/>
@@ -5031,15 +4517,15 @@
           <a:lstStyle/>
           <a:p>
             <a:pPr>
-              <a:defRPr sz="1500">
-                <a:solidFill>
-                  <a:srgbClr val="9AA6B6"/>
-                </a:solidFill>
-                <a:latin typeface="Segoe UI"/>
-              </a:defRPr>
-            </a:pPr>
-            <a:r>
-              <a:t>Directing traffic from legacy monolith to modernized services behind living specs.</a:t>
+              <a:defRPr sz="1700">
+                <a:solidFill>
+                  <a:srgbClr val="94A3B8"/>
+                </a:solidFill>
+                <a:latin typeface="Segoe UI"/>
+              </a:defRPr>
+            </a:pPr>
+            <a:r>
+              <a:t>Using discovery dependencies to sequence unblocked epics while running repo setup and specs in parallel.</a:t>
             </a:r>
           </a:p>
         </p:txBody>
@@ -5052,8 +4538,8 @@
         </p:nvSpPr>
         <p:spPr>
           <a:xfrm>
-            <a:off x="731520" y="2377440"/>
-            <a:ext cx="10515600" cy="3840480"/>
+            <a:off x="731520" y="2468880"/>
+            <a:ext cx="10515600" cy="3931920"/>
           </a:xfrm>
           <a:prstGeom prst="rect">
             <a:avLst/>
@@ -5068,65 +4554,65 @@
           <a:p>
             <a:pPr>
               <a:spcAft>
-                <a:spcPts val="1600"/>
+                <a:spcPts val="2000"/>
               </a:spcAft>
-              <a:defRPr sz="1600">
-                <a:solidFill>
-                  <a:srgbClr val="E6EBF2"/>
-                </a:solidFill>
-                <a:latin typeface="Segoe UI"/>
-              </a:defRPr>
-            </a:pPr>
-            <a:r>
-              <a:t>• Clients &amp; Users: Single entry point through Reverse Proxy / API Facade Router.</a:t>
+              <a:defRPr sz="1800">
+                <a:solidFill>
+                  <a:srgbClr val="F1F5F9"/>
+                </a:solidFill>
+                <a:latin typeface="Segoe UI"/>
+              </a:defRPr>
+            </a:pPr>
+            <a:r>
+              <a:t>•  Dependency-Driven Selection: /tech-doc maps call graphs to pick unblocked epics with zero upstream blockers.</a:t>
             </a:r>
           </a:p>
           <a:p>
             <a:pPr>
               <a:spcAft>
-                <a:spcPts val="1600"/>
+                <a:spcPts val="2000"/>
               </a:spcAft>
-              <a:defRPr sz="1600">
-                <a:solidFill>
-                  <a:srgbClr val="E6EBF2"/>
-                </a:solidFill>
-                <a:latin typeface="Segoe UI"/>
-              </a:defRPr>
-            </a:pPr>
-            <a:r>
-              <a:t>• Legacy Monolith: Subsystems remain operational while being systematically isolated.</a:t>
+              <a:defRPr sz="1800">
+                <a:solidFill>
+                  <a:srgbClr val="F1F5F9"/>
+                </a:solidFill>
+                <a:latin typeface="Segoe UI"/>
+              </a:defRPr>
+            </a:pPr>
+            <a:r>
+              <a:t>•  Specs Worth the Investment: Coding never starts on unconfirmed specs; premature coding causes severe rework.</a:t>
             </a:r>
           </a:p>
           <a:p>
             <a:pPr>
               <a:spcAft>
-                <a:spcPts val="1600"/>
+                <a:spcPts val="2000"/>
               </a:spcAft>
-              <a:defRPr sz="1600">
-                <a:solidFill>
-                  <a:srgbClr val="E6EBF2"/>
-                </a:solidFill>
-                <a:latin typeface="Segoe UI"/>
-              </a:defRPr>
-            </a:pPr>
-            <a:r>
-              <a:t>• Modernized Services: Capability cores defined by living specs (docs/specs/&lt;cap&gt;/spec.md).</a:t>
+              <a:defRPr sz="1800">
+                <a:solidFill>
+                  <a:srgbClr val="F1F5F9"/>
+                </a:solidFill>
+                <a:latin typeface="Segoe UI"/>
+              </a:defRPr>
+            </a:pPr>
+            <a:r>
+              <a:t>•  Parallel Early Sprints: Engineering stabilizes legacy app &amp; scaffolds repos while BA deep-dives into specs.</a:t>
             </a:r>
           </a:p>
           <a:p>
             <a:pPr>
               <a:spcAft>
-                <a:spcPts val="1600"/>
+                <a:spcPts val="2000"/>
               </a:spcAft>
-              <a:defRPr sz="1600">
-                <a:solidFill>
-                  <a:srgbClr val="E6EBF2"/>
-                </a:solidFill>
-                <a:latin typeface="Segoe UI"/>
-              </a:defRPr>
-            </a:pPr>
-            <a:r>
-              <a:t>• Continuous Verification: Automated Playwright E2E suites ensure parity before legacy routes are retired.</a:t>
+              <a:defRPr sz="1800">
+                <a:solidFill>
+                  <a:srgbClr val="F1F5F9"/>
+                </a:solidFill>
+                <a:latin typeface="Segoe UI"/>
+              </a:defRPr>
+            </a:pPr>
+            <a:r>
+              <a:t>•  Milestone Convergence: Sprint 1 delivers operational dev environments + 100% confirmed spec ready for implementation.</a:t>
             </a:r>
           </a:p>
         </p:txBody>
@@ -5164,7 +4650,7 @@
             <a:avLst/>
           </a:prstGeom>
           <a:solidFill>
-            <a:srgbClr val="0F141B"/>
+            <a:srgbClr val="0B0F15"/>
           </a:solidFill>
           <a:ln>
             <a:noFill/>
@@ -5215,15 +4701,15 @@
           <a:lstStyle/>
           <a:p>
             <a:pPr>
-              <a:defRPr sz="1300" b="1">
-                <a:solidFill>
-                  <a:srgbClr val="7EA2FF"/>
-                </a:solidFill>
-                <a:latin typeface="Segoe UI"/>
-              </a:defRPr>
-            </a:pPr>
-            <a:r>
-              <a:t>PHASE 0: DISCOVERY</a:t>
+              <a:defRPr sz="1400" b="1">
+                <a:solidFill>
+                  <a:srgbClr val="60A5FA"/>
+                </a:solidFill>
+                <a:latin typeface="Segoe UI"/>
+              </a:defRPr>
+            </a:pPr>
+            <a:r>
+              <a:t>TEAM GOVERNANCE</a:t>
             </a:r>
           </a:p>
         </p:txBody>
@@ -5251,15 +4737,15 @@
           <a:lstStyle/>
           <a:p>
             <a:pPr>
-              <a:defRPr sz="2600" b="1">
-                <a:solidFill>
-                  <a:srgbClr val="E6EBF2"/>
-                </a:solidFill>
-                <a:latin typeface="Segoe UI"/>
-              </a:defRPr>
-            </a:pPr>
-            <a:r>
-              <a:t>Automated Discovery of Legacy Codebases</a:t>
+              <a:defRPr sz="2800" b="1">
+                <a:solidFill>
+                  <a:srgbClr val="F1F5F9"/>
+                </a:solidFill>
+                <a:latin typeface="Segoe UI"/>
+              </a:defRPr>
+            </a:pPr>
+            <a:r>
+              <a:t>Cross-Functional Roles in the Modernization Lifecycle</a:t>
             </a:r>
           </a:p>
         </p:txBody>
@@ -5272,8 +4758,8 @@
         </p:nvSpPr>
         <p:spPr>
           <a:xfrm>
-            <a:off x="731520" y="1645920"/>
-            <a:ext cx="10515600" cy="457200"/>
+            <a:off x="731520" y="1691640"/>
+            <a:ext cx="10515600" cy="502920"/>
           </a:xfrm>
           <a:prstGeom prst="rect">
             <a:avLst/>
@@ -5287,15 +4773,15 @@
           <a:lstStyle/>
           <a:p>
             <a:pPr>
-              <a:defRPr sz="1500">
-                <a:solidFill>
-                  <a:srgbClr val="9AA6B6"/>
-                </a:solidFill>
-                <a:latin typeface="Segoe UI"/>
-              </a:defRPr>
-            </a:pPr>
-            <a:r>
-              <a:t>Extracting architecture and boundary contracts directly from repository evidence.</a:t>
+              <a:defRPr sz="1700">
+                <a:solidFill>
+                  <a:srgbClr val="94A3B8"/>
+                </a:solidFill>
+                <a:latin typeface="Segoe UI"/>
+              </a:defRPr>
+            </a:pPr>
+            <a:r>
+              <a:t>Structured division of responsibilities with pull-request verified quality gates.</a:t>
             </a:r>
           </a:p>
         </p:txBody>
@@ -5308,8 +4794,8 @@
         </p:nvSpPr>
         <p:spPr>
           <a:xfrm>
-            <a:off x="731520" y="2377440"/>
-            <a:ext cx="10515600" cy="3840480"/>
+            <a:off x="731520" y="2468880"/>
+            <a:ext cx="10515600" cy="3931920"/>
           </a:xfrm>
           <a:prstGeom prst="rect">
             <a:avLst/>
@@ -5324,65 +4810,65 @@
           <a:p>
             <a:pPr>
               <a:spcAft>
-                <a:spcPts val="1600"/>
+                <a:spcPts val="2000"/>
               </a:spcAft>
-              <a:defRPr sz="1600">
-                <a:solidFill>
-                  <a:srgbClr val="E6EBF2"/>
-                </a:solidFill>
-                <a:latin typeface="Segoe UI"/>
-              </a:defRPr>
-            </a:pPr>
-            <a:r>
-              <a:t>• The Legacy Gap: Outdated wikis, undocumented business logic, hidden database triggers.</a:t>
+              <a:defRPr sz="1800">
+                <a:solidFill>
+                  <a:srgbClr val="F1F5F9"/>
+                </a:solidFill>
+                <a:latin typeface="Segoe UI"/>
+              </a:defRPr>
+            </a:pPr>
+            <a:r>
+              <a:t>•  Product Manager (PM): Owns docs/roadmap.md, tags sprint epics, tracks delivery milestones.</a:t>
             </a:r>
           </a:p>
           <a:p>
             <a:pPr>
               <a:spcAft>
-                <a:spcPts val="1600"/>
+                <a:spcPts val="2000"/>
               </a:spcAft>
-              <a:defRPr sz="1600">
-                <a:solidFill>
-                  <a:srgbClr val="E6EBF2"/>
-                </a:solidFill>
-                <a:latin typeface="Segoe UI"/>
-              </a:defRPr>
-            </a:pPr>
-            <a:r>
-              <a:t>• Extraction via /tech-doc: Scans AST, routing tables, and schemas directly from source code.</a:t>
+              <a:defRPr sz="1800">
+                <a:solidFill>
+                  <a:srgbClr val="F1F5F9"/>
+                </a:solidFill>
+                <a:latin typeface="Segoe UI"/>
+              </a:defRPr>
+            </a:pPr>
+            <a:r>
+              <a:t>•  Business Analyst (BA): Owns living specs, writes EARS requirements, attaches UI mockups, signs PR gates.</a:t>
             </a:r>
           </a:p>
           <a:p>
             <a:pPr>
               <a:spcAft>
-                <a:spcPts val="1600"/>
+                <a:spcPts val="2000"/>
               </a:spcAft>
-              <a:defRPr sz="1600">
-                <a:solidFill>
-                  <a:srgbClr val="E6EBF2"/>
-                </a:solidFill>
-                <a:latin typeface="Segoe UI"/>
-              </a:defRPr>
-            </a:pPr>
-            <a:r>
-              <a:t>• Standardized Architecture Baseline: 10 structured docs under docs/codebase/ (API, ARCHITECTURE, STACK).</a:t>
+              <a:defRPr sz="1800">
+                <a:solidFill>
+                  <a:srgbClr val="F1F5F9"/>
+                </a:solidFill>
+                <a:latin typeface="Segoe UI"/>
+              </a:defRPr>
+            </a:pPr>
+            <a:r>
+              <a:t>•  Tech Lead &amp; Developers: Decompose architecture into bounded tracks, develop test-first in Git worktrees.</a:t>
             </a:r>
           </a:p>
           <a:p>
             <a:pPr>
               <a:spcAft>
-                <a:spcPts val="1600"/>
+                <a:spcPts val="2000"/>
               </a:spcAft>
-              <a:defRPr sz="1600">
-                <a:solidFill>
-                  <a:srgbClr val="E6EBF2"/>
-                </a:solidFill>
-                <a:latin typeface="Segoe UI"/>
-              </a:defRPr>
-            </a:pPr>
-            <a:r>
-              <a:t>• Zero Speculation: Every finding links to exact repository lines rather than subjective memory.</a:t>
+              <a:defRPr sz="1800">
+                <a:solidFill>
+                  <a:srgbClr val="F1F5F9"/>
+                </a:solidFill>
+                <a:latin typeface="Segoe UI"/>
+              </a:defRPr>
+            </a:pPr>
+            <a:r>
+              <a:t>•  Quality Engineering (QE/QA): Generates test cases from specs, tracks drift, approves ship gates.</a:t>
             </a:r>
           </a:p>
         </p:txBody>
@@ -5420,7 +4906,7 @@
             <a:avLst/>
           </a:prstGeom>
           <a:solidFill>
-            <a:srgbClr val="0F141B"/>
+            <a:srgbClr val="0B0F15"/>
           </a:solidFill>
           <a:ln>
             <a:noFill/>
@@ -5471,15 +4957,15 @@
           <a:lstStyle/>
           <a:p>
             <a:pPr>
-              <a:defRPr sz="1300" b="1">
-                <a:solidFill>
-                  <a:srgbClr val="7EA2FF"/>
-                </a:solidFill>
-                <a:latin typeface="Segoe UI"/>
-              </a:defRPr>
-            </a:pPr>
-            <a:r>
-              <a:t>ROADMAP GOVERNANCE</a:t>
+              <a:defRPr sz="1400" b="1">
+                <a:solidFill>
+                  <a:srgbClr val="60A5FA"/>
+                </a:solidFill>
+                <a:latin typeface="Segoe UI"/>
+              </a:defRPr>
+            </a:pPr>
+            <a:r>
+              <a:t>STAGE 1: DISCUSS</a:t>
             </a:r>
           </a:p>
         </p:txBody>
@@ -5507,15 +4993,15 @@
           <a:lstStyle/>
           <a:p>
             <a:pPr>
-              <a:defRPr sz="2600" b="1">
-                <a:solidFill>
-                  <a:srgbClr val="E6EBF2"/>
-                </a:solidFill>
-                <a:latin typeface="Segoe UI"/>
-              </a:defRPr>
-            </a:pPr>
-            <a:r>
-              <a:t>Roadmap Sequencing &amp; Parallel Early Sprints</a:t>
+              <a:defRPr sz="2800" b="1">
+                <a:solidFill>
+                  <a:srgbClr val="F1F5F9"/>
+                </a:solidFill>
+                <a:latin typeface="Segoe UI"/>
+              </a:defRPr>
+            </a:pPr>
+            <a:r>
+              <a:t>How AI-Generated Specifications Are Formally Verified</a:t>
             </a:r>
           </a:p>
         </p:txBody>
@@ -5528,8 +5014,8 @@
         </p:nvSpPr>
         <p:spPr>
           <a:xfrm>
-            <a:off x="731520" y="1645920"/>
-            <a:ext cx="10515600" cy="457200"/>
+            <a:off x="731520" y="1691640"/>
+            <a:ext cx="10515600" cy="502920"/>
           </a:xfrm>
           <a:prstGeom prst="rect">
             <a:avLst/>
@@ -5543,15 +5029,15 @@
           <a:lstStyle/>
           <a:p>
             <a:pPr>
-              <a:defRPr sz="1500">
-                <a:solidFill>
-                  <a:srgbClr val="9AA6B6"/>
-                </a:solidFill>
-                <a:latin typeface="Segoe UI"/>
-              </a:defRPr>
-            </a:pPr>
-            <a:r>
-              <a:t>Using discovery dependencies to sequence unblocked epics while running repo setup and specs in parallel.</a:t>
+              <a:defRPr sz="1700">
+                <a:solidFill>
+                  <a:srgbClr val="94A3B8"/>
+                </a:solidFill>
+                <a:latin typeface="Segoe UI"/>
+              </a:defRPr>
+            </a:pPr>
+            <a:r>
+              <a:t>Eliminating hallucinations through deterministic grammar and human PR review gates.</a:t>
             </a:r>
           </a:p>
         </p:txBody>
@@ -5564,8 +5050,8 @@
         </p:nvSpPr>
         <p:spPr>
           <a:xfrm>
-            <a:off x="731520" y="2377440"/>
-            <a:ext cx="10515600" cy="3840480"/>
+            <a:off x="731520" y="2468880"/>
+            <a:ext cx="10515600" cy="3931920"/>
           </a:xfrm>
           <a:prstGeom prst="rect">
             <a:avLst/>
@@ -5580,65 +5066,65 @@
           <a:p>
             <a:pPr>
               <a:spcAft>
-                <a:spcPts val="1600"/>
+                <a:spcPts val="2000"/>
               </a:spcAft>
-              <a:defRPr sz="1600">
-                <a:solidFill>
-                  <a:srgbClr val="E6EBF2"/>
-                </a:solidFill>
-                <a:latin typeface="Segoe UI"/>
-              </a:defRPr>
-            </a:pPr>
-            <a:r>
-              <a:t>• Dependency Mapping: /tech-doc maps legacy call graphs and data dependencies to prioritize unblocked modules.</a:t>
+              <a:defRPr sz="1800">
+                <a:solidFill>
+                  <a:srgbClr val="F1F5F9"/>
+                </a:solidFill>
+                <a:latin typeface="Segoe UI"/>
+              </a:defRPr>
+            </a:pPr>
+            <a:r>
+              <a:t>•  Deterministic Grammar: Strict EARS syntax (SHALL/MUST) and mandatory GIVEN/WHEN/THEN scenarios.</a:t>
             </a:r>
           </a:p>
           <a:p>
             <a:pPr>
               <a:spcAft>
-                <a:spcPts val="1600"/>
+                <a:spcPts val="2000"/>
               </a:spcAft>
-              <a:defRPr sz="1600">
-                <a:solidFill>
-                  <a:srgbClr val="E6EBF2"/>
-                </a:solidFill>
-                <a:latin typeface="Segoe UI"/>
-              </a:defRPr>
-            </a:pPr>
-            <a:r>
-              <a:t>• Specs Worth the Investment: Coding never starts on unconfirmed specs; premature coding causes severe rework.</a:t>
+              <a:defRPr sz="1800">
+                <a:solidFill>
+                  <a:srgbClr val="F1F5F9"/>
+                </a:solidFill>
+                <a:latin typeface="Segoe UI"/>
+              </a:defRPr>
+            </a:pPr>
+            <a:r>
+              <a:t>•  Automated Syntax Audit: specs lint immediately rejects malformed formatting or missing scenarios.</a:t>
             </a:r>
           </a:p>
           <a:p>
             <a:pPr>
               <a:spcAft>
-                <a:spcPts val="1600"/>
+                <a:spcPts val="2000"/>
               </a:spcAft>
-              <a:defRPr sz="1600">
-                <a:solidFill>
-                  <a:srgbClr val="E6EBF2"/>
-                </a:solidFill>
-                <a:latin typeface="Segoe UI"/>
-              </a:defRPr>
-            </a:pPr>
-            <a:r>
-              <a:t>• Parallel Early Sprints: Engineering stabilizes legacy app &amp; scaffolds repos while BA deep-dives into specs.</a:t>
+              <a:defRPr sz="1800">
+                <a:solidFill>
+                  <a:srgbClr val="F1F5F9"/>
+                </a:solidFill>
+                <a:latin typeface="Segoe UI"/>
+              </a:defRPr>
+            </a:pPr>
+            <a:r>
+              <a:t>•  Human Pull Request Gate: Spec changes committed on spec/&lt;topic&gt;; gate requires human BA approval.</a:t>
             </a:r>
           </a:p>
           <a:p>
             <a:pPr>
               <a:spcAft>
-                <a:spcPts val="1600"/>
+                <a:spcPts val="2000"/>
               </a:spcAft>
-              <a:defRPr sz="1600">
-                <a:solidFill>
-                  <a:srgbClr val="E6EBF2"/>
-                </a:solidFill>
-                <a:latin typeface="Segoe UI"/>
-              </a:defRPr>
-            </a:pPr>
-            <a:r>
-              <a:t>• Execution Transition: Once repos are ready and spec is confirmed (PR gate), Dev executes TDD implementation.</a:t>
+              <a:defRPr sz="1800">
+                <a:solidFill>
+                  <a:srgbClr val="F1F5F9"/>
+                </a:solidFill>
+                <a:latin typeface="Segoe UI"/>
+              </a:defRPr>
+            </a:pPr>
+            <a:r>
+              <a:t>•  Visual Asset Grounding: BAs save wireframes into docs/specs/&lt;cap&gt;/assets/ for multimodal extraction.</a:t>
             </a:r>
           </a:p>
         </p:txBody>
@@ -5676,7 +5162,7 @@
             <a:avLst/>
           </a:prstGeom>
           <a:solidFill>
-            <a:srgbClr val="0F141B"/>
+            <a:srgbClr val="0B0F15"/>
           </a:solidFill>
           <a:ln>
             <a:noFill/>
@@ -5727,15 +5213,15 @@
           <a:lstStyle/>
           <a:p>
             <a:pPr>
-              <a:defRPr sz="1300" b="1">
-                <a:solidFill>
-                  <a:srgbClr val="7EA2FF"/>
-                </a:solidFill>
-                <a:latin typeface="Segoe UI"/>
-              </a:defRPr>
-            </a:pPr>
-            <a:r>
-              <a:t>TEAM GOVERNANCE</a:t>
+              <a:defRPr sz="1400" b="1">
+                <a:solidFill>
+                  <a:srgbClr val="60A5FA"/>
+                </a:solidFill>
+                <a:latin typeface="Segoe UI"/>
+              </a:defRPr>
+            </a:pPr>
+            <a:r>
+              <a:t>STAGES 2 &amp; 3: PLAN &amp; ORCHESTRATE</a:t>
             </a:r>
           </a:p>
         </p:txBody>
@@ -5763,15 +5249,15 @@
           <a:lstStyle/>
           <a:p>
             <a:pPr>
-              <a:defRPr sz="2600" b="1">
-                <a:solidFill>
-                  <a:srgbClr val="E6EBF2"/>
-                </a:solidFill>
-                <a:latin typeface="Segoe UI"/>
-              </a:defRPr>
-            </a:pPr>
-            <a:r>
-              <a:t>Cross-Functional Roles in the Modernization Lifecycle</a:t>
+              <a:defRPr sz="2800" b="1">
+                <a:solidFill>
+                  <a:srgbClr val="F1F5F9"/>
+                </a:solidFill>
+                <a:latin typeface="Segoe UI"/>
+              </a:defRPr>
+            </a:pPr>
+            <a:r>
+              <a:t>Architectural Decomposition, Worktrees &amp; Model Routing</a:t>
             </a:r>
           </a:p>
         </p:txBody>
@@ -5784,8 +5270,8 @@
         </p:nvSpPr>
         <p:spPr>
           <a:xfrm>
-            <a:off x="731520" y="1645920"/>
-            <a:ext cx="10515600" cy="457200"/>
+            <a:off x="731520" y="1691640"/>
+            <a:ext cx="10515600" cy="502920"/>
           </a:xfrm>
           <a:prstGeom prst="rect">
             <a:avLst/>
@@ -5799,15 +5285,15 @@
           <a:lstStyle/>
           <a:p>
             <a:pPr>
-              <a:defRPr sz="1500">
-                <a:solidFill>
-                  <a:srgbClr val="9AA6B6"/>
-                </a:solidFill>
-                <a:latin typeface="Segoe UI"/>
-              </a:defRPr>
-            </a:pPr>
-            <a:r>
-              <a:t>Structured division of responsibilities with pull-request verified quality gates.</a:t>
+              <a:defRPr sz="1700">
+                <a:solidFill>
+                  <a:srgbClr val="94A3B8"/>
+                </a:solidFill>
+                <a:latin typeface="Segoe UI"/>
+              </a:defRPr>
+            </a:pPr>
+            <a:r>
+              <a:t>Enforcing subsystem boundaries, isolating workspaces, and routing models by task complexity.</a:t>
             </a:r>
           </a:p>
         </p:txBody>
@@ -5820,8 +5306,8 @@
         </p:nvSpPr>
         <p:spPr>
           <a:xfrm>
-            <a:off x="731520" y="2377440"/>
-            <a:ext cx="10515600" cy="3840480"/>
+            <a:off x="731520" y="2468880"/>
+            <a:ext cx="10515600" cy="3931920"/>
           </a:xfrm>
           <a:prstGeom prst="rect">
             <a:avLst/>
@@ -5836,65 +5322,65 @@
           <a:p>
             <a:pPr>
               <a:spcAft>
-                <a:spcPts val="1600"/>
+                <a:spcPts val="2000"/>
               </a:spcAft>
-              <a:defRPr sz="1600">
-                <a:solidFill>
-                  <a:srgbClr val="E6EBF2"/>
-                </a:solidFill>
-                <a:latin typeface="Segoe UI"/>
-              </a:defRPr>
-            </a:pPr>
-            <a:r>
-              <a:t>• Product Manager (PM): Owns docs/roadmap.md, tags sprint epics, tracks delivery milestones.</a:t>
+              <a:defRPr sz="1800">
+                <a:solidFill>
+                  <a:srgbClr val="F1F5F9"/>
+                </a:solidFill>
+                <a:latin typeface="Segoe UI"/>
+              </a:defRPr>
+            </a:pPr>
+            <a:r>
+              <a:t>•  Bounded Area Scoping: Tracks declare Area (e.g. Area: modern_api); out-of-boundary edits are rejected.</a:t>
             </a:r>
           </a:p>
           <a:p>
             <a:pPr>
               <a:spcAft>
-                <a:spcPts val="1600"/>
+                <a:spcPts val="2000"/>
               </a:spcAft>
-              <a:defRPr sz="1600">
-                <a:solidFill>
-                  <a:srgbClr val="E6EBF2"/>
-                </a:solidFill>
-                <a:latin typeface="Segoe UI"/>
-              </a:defRPr>
-            </a:pPr>
-            <a:r>
-              <a:t>• Business Analyst (BA): Owns living specs, writes EARS requirements, attaches UI mockups, signs PR gates.</a:t>
+              <a:defRPr sz="1800">
+                <a:solidFill>
+                  <a:srgbClr val="F1F5F9"/>
+                </a:solidFill>
+                <a:latin typeface="Segoe UI"/>
+              </a:defRPr>
+            </a:pPr>
+            <a:r>
+              <a:t>•  Git Worktree Isolation: /orchestrate provisions clean worktrees in .planning/worktrees/ for each track.</a:t>
             </a:r>
           </a:p>
           <a:p>
             <a:pPr>
               <a:spcAft>
-                <a:spcPts val="1600"/>
+                <a:spcPts val="2000"/>
               </a:spcAft>
-              <a:defRPr sz="1600">
-                <a:solidFill>
-                  <a:srgbClr val="E6EBF2"/>
-                </a:solidFill>
-                <a:latin typeface="Segoe UI"/>
-              </a:defRPr>
-            </a:pPr>
-            <a:r>
-              <a:t>• Tech Lead &amp; Developers: Decompose architecture into bounded tracks, develop test-first in Git worktrees.</a:t>
+              <a:defRPr sz="1800">
+                <a:solidFill>
+                  <a:srgbClr val="F1F5F9"/>
+                </a:solidFill>
+                <a:latin typeface="Segoe UI"/>
+              </a:defRPr>
+            </a:pPr>
+            <a:r>
+              <a:t>•  Zero Git Collisions: Multiple developers and AI agents build and test simultaneously without branch locking.</a:t>
             </a:r>
           </a:p>
           <a:p>
             <a:pPr>
               <a:spcAft>
-                <a:spcPts val="1600"/>
+                <a:spcPts val="2000"/>
               </a:spcAft>
-              <a:defRPr sz="1600">
-                <a:solidFill>
-                  <a:srgbClr val="E6EBF2"/>
-                </a:solidFill>
-                <a:latin typeface="Segoe UI"/>
-              </a:defRPr>
-            </a:pPr>
-            <a:r>
-              <a:t>• Quality Engineering (QE/QA): Generates test cases from specs, tracks drift, approves ship gates.</a:t>
+              <a:defRPr sz="1800">
+                <a:solidFill>
+                  <a:srgbClr val="F1F5F9"/>
+                </a:solidFill>
+                <a:latin typeface="Segoe UI"/>
+              </a:defRPr>
+            </a:pPr>
+            <a:r>
+              <a:t>•  Complexity-Based Routing: Orchestrator evaluates track difficulty to assign optimal reasoning tiers (low/med/high).</a:t>
             </a:r>
           </a:p>
         </p:txBody>
@@ -5932,7 +5418,7 @@
             <a:avLst/>
           </a:prstGeom>
           <a:solidFill>
-            <a:srgbClr val="0F141B"/>
+            <a:srgbClr val="0B0F15"/>
           </a:solidFill>
           <a:ln>
             <a:noFill/>
@@ -5983,15 +5469,15 @@
           <a:lstStyle/>
           <a:p>
             <a:pPr>
-              <a:defRPr sz="1300" b="1">
-                <a:solidFill>
-                  <a:srgbClr val="7EA2FF"/>
-                </a:solidFill>
-                <a:latin typeface="Segoe UI"/>
-              </a:defRPr>
-            </a:pPr>
-            <a:r>
-              <a:t>QUALITY GATE: DISCUSS</a:t>
+              <a:defRPr sz="1400" b="1">
+                <a:solidFill>
+                  <a:srgbClr val="60A5FA"/>
+                </a:solidFill>
+                <a:latin typeface="Segoe UI"/>
+              </a:defRPr>
+            </a:pPr>
+            <a:r>
+              <a:t>STAGE 4: EXECUTE</a:t>
             </a:r>
           </a:p>
         </p:txBody>
@@ -6019,15 +5505,15 @@
           <a:lstStyle/>
           <a:p>
             <a:pPr>
-              <a:defRPr sz="2600" b="1">
-                <a:solidFill>
-                  <a:srgbClr val="E6EBF2"/>
-                </a:solidFill>
-                <a:latin typeface="Segoe UI"/>
-              </a:defRPr>
-            </a:pPr>
-            <a:r>
-              <a:t>How AI-Generated Specifications Are Formally Verified</a:t>
+              <a:defRPr sz="2800" b="1">
+                <a:solidFill>
+                  <a:srgbClr val="F1F5F9"/>
+                </a:solidFill>
+                <a:latin typeface="Segoe UI"/>
+              </a:defRPr>
+            </a:pPr>
+            <a:r>
+              <a:t>Ensuring Code Strictly Matches Specification</a:t>
             </a:r>
           </a:p>
         </p:txBody>
@@ -6040,8 +5526,8 @@
         </p:nvSpPr>
         <p:spPr>
           <a:xfrm>
-            <a:off x="731520" y="1645920"/>
-            <a:ext cx="10515600" cy="457200"/>
+            <a:off x="731520" y="1691640"/>
+            <a:ext cx="10515600" cy="502920"/>
           </a:xfrm>
           <a:prstGeom prst="rect">
             <a:avLst/>
@@ -6055,15 +5541,15 @@
           <a:lstStyle/>
           <a:p>
             <a:pPr>
-              <a:defRPr sz="1500">
-                <a:solidFill>
-                  <a:srgbClr val="9AA6B6"/>
-                </a:solidFill>
-                <a:latin typeface="Segoe UI"/>
-              </a:defRPr>
-            </a:pPr>
-            <a:r>
-              <a:t>Eliminating hallucinations through deterministic grammar and human PR review gates.</a:t>
+              <a:defRPr sz="1700">
+                <a:solidFill>
+                  <a:srgbClr val="94A3B8"/>
+                </a:solidFill>
+                <a:latin typeface="Segoe UI"/>
+              </a:defRPr>
+            </a:pPr>
+            <a:r>
+              <a:t>Guaranteed compliance through bidirectional requirement tagging and automated trace audits.</a:t>
             </a:r>
           </a:p>
         </p:txBody>
@@ -6076,8 +5562,8 @@
         </p:nvSpPr>
         <p:spPr>
           <a:xfrm>
-            <a:off x="731520" y="2377440"/>
-            <a:ext cx="10515600" cy="3840480"/>
+            <a:off x="731520" y="2468880"/>
+            <a:ext cx="10515600" cy="3931920"/>
           </a:xfrm>
           <a:prstGeom prst="rect">
             <a:avLst/>
@@ -6092,65 +5578,65 @@
           <a:p>
             <a:pPr>
               <a:spcAft>
-                <a:spcPts val="1600"/>
+                <a:spcPts val="2000"/>
               </a:spcAft>
-              <a:defRPr sz="1600">
-                <a:solidFill>
-                  <a:srgbClr val="E6EBF2"/>
-                </a:solidFill>
-                <a:latin typeface="Segoe UI"/>
-              </a:defRPr>
-            </a:pPr>
-            <a:r>
-              <a:t>• Deterministic EARS Grammar: Requirements must declare SHALL/MUST statements and GIVEN/WHEN/THEN scenarios.</a:t>
+              <a:defRPr sz="1800">
+                <a:solidFill>
+                  <a:srgbClr val="F1F5F9"/>
+                </a:solidFill>
+                <a:latin typeface="Segoe UI"/>
+              </a:defRPr>
+            </a:pPr>
+            <a:r>
+              <a:t>•  Bidirectional Linkage: Living Spec REQ-ID -&gt; plan.md Track -&gt; Test # REQ-ID -&gt; Implementation.</a:t>
             </a:r>
           </a:p>
           <a:p>
             <a:pPr>
               <a:spcAft>
-                <a:spcPts val="1600"/>
+                <a:spcPts val="2000"/>
               </a:spcAft>
-              <a:defRPr sz="1600">
-                <a:solidFill>
-                  <a:srgbClr val="E6EBF2"/>
-                </a:solidFill>
-                <a:latin typeface="Segoe UI"/>
-              </a:defRPr>
-            </a:pPr>
-            <a:r>
-              <a:t>• Automated Syntax Audit: specs lint immediately fails invalid formatting or orphaned scenarios.</a:t>
+              <a:defRPr sz="1800">
+                <a:solidFill>
+                  <a:srgbClr val="F1F5F9"/>
+                </a:solidFill>
+                <a:latin typeface="Segoe UI"/>
+              </a:defRPr>
+            </a:pPr>
+            <a:r>
+              <a:t>•  Test-Driven Development: Failing unit/integration tests must precede implementation code.</a:t>
             </a:r>
           </a:p>
           <a:p>
             <a:pPr>
               <a:spcAft>
-                <a:spcPts val="1600"/>
+                <a:spcPts val="2000"/>
               </a:spcAft>
-              <a:defRPr sz="1600">
-                <a:solidFill>
-                  <a:srgbClr val="E6EBF2"/>
-                </a:solidFill>
-                <a:latin typeface="Segoe UI"/>
-              </a:defRPr>
-            </a:pPr>
-            <a:r>
-              <a:t>• Human Pull Request Gate: Spec changes are committed on spec/&lt;topic&gt;; gate requires human BA approval.</a:t>
+              <a:defRPr sz="1800">
+                <a:solidFill>
+                  <a:srgbClr val="F1F5F9"/>
+                </a:solidFill>
+                <a:latin typeface="Segoe UI"/>
+              </a:defRPr>
+            </a:pPr>
+            <a:r>
+              <a:t>•  Automated Audit (specs trace): Audits codebase to ensure 100% of requirement scenarios have tests.</a:t>
             </a:r>
           </a:p>
           <a:p>
             <a:pPr>
               <a:spcAft>
-                <a:spcPts val="1600"/>
+                <a:spcPts val="2000"/>
               </a:spcAft>
-              <a:defRPr sz="1600">
-                <a:solidFill>
-                  <a:srgbClr val="E6EBF2"/>
-                </a:solidFill>
-                <a:latin typeface="Segoe UI"/>
-              </a:defRPr>
-            </a:pPr>
-            <a:r>
-              <a:t>• Visual Asset Grounding: Wireframes attached in docs/specs/&lt;cap&gt;/assets/ ground UI requirements.</a:t>
+              <a:defRPr sz="1800">
+                <a:solidFill>
+                  <a:srgbClr val="F1F5F9"/>
+                </a:solidFill>
+                <a:latin typeface="Segoe UI"/>
+              </a:defRPr>
+            </a:pPr>
+            <a:r>
+              <a:t>•  Zero Tolerance: Missing requirement tests block the verification and ship gates.</a:t>
             </a:r>
           </a:p>
         </p:txBody>
@@ -6188,7 +5674,7 @@
             <a:avLst/>
           </a:prstGeom>
           <a:solidFill>
-            <a:srgbClr val="0F141B"/>
+            <a:srgbClr val="0B0F15"/>
           </a:solidFill>
           <a:ln>
             <a:noFill/>
@@ -6239,15 +5725,15 @@
           <a:lstStyle/>
           <a:p>
             <a:pPr>
-              <a:defRPr sz="1300" b="1">
-                <a:solidFill>
-                  <a:srgbClr val="7EA2FF"/>
-                </a:solidFill>
-                <a:latin typeface="Segoe UI"/>
-              </a:defRPr>
-            </a:pPr>
-            <a:r>
-              <a:t>STAGES 2 &amp; 3: PLAN &amp; ORCHESTRATE</a:t>
+              <a:defRPr sz="1400" b="1">
+                <a:solidFill>
+                  <a:srgbClr val="60A5FA"/>
+                </a:solidFill>
+                <a:latin typeface="Segoe UI"/>
+              </a:defRPr>
+            </a:pPr>
+            <a:r>
+              <a:t>VERIFICATION</a:t>
             </a:r>
           </a:p>
         </p:txBody>
@@ -6275,15 +5761,15 @@
           <a:lstStyle/>
           <a:p>
             <a:pPr>
-              <a:defRPr sz="2600" b="1">
-                <a:solidFill>
-                  <a:srgbClr val="E6EBF2"/>
-                </a:solidFill>
-                <a:latin typeface="Segoe UI"/>
-              </a:defRPr>
-            </a:pPr>
-            <a:r>
-              <a:t>Architectural Decomposition, Worktrees &amp; Model Routing</a:t>
+              <a:defRPr sz="2800" b="1">
+                <a:solidFill>
+                  <a:srgbClr val="F1F5F9"/>
+                </a:solidFill>
+                <a:latin typeface="Segoe UI"/>
+              </a:defRPr>
+            </a:pPr>
+            <a:r>
+              <a:t>Independent Code Review &amp; The Review Ledger</a:t>
             </a:r>
           </a:p>
         </p:txBody>
@@ -6296,8 +5782,8 @@
         </p:nvSpPr>
         <p:spPr>
           <a:xfrm>
-            <a:off x="731520" y="1645920"/>
-            <a:ext cx="10515600" cy="457200"/>
+            <a:off x="731520" y="1691640"/>
+            <a:ext cx="10515600" cy="502920"/>
           </a:xfrm>
           <a:prstGeom prst="rect">
             <a:avLst/>
@@ -6311,15 +5797,15 @@
           <a:lstStyle/>
           <a:p>
             <a:pPr>
-              <a:defRPr sz="1500">
-                <a:solidFill>
-                  <a:srgbClr val="9AA6B6"/>
-                </a:solidFill>
-                <a:latin typeface="Segoe UI"/>
-              </a:defRPr>
-            </a:pPr>
-            <a:r>
-              <a:t>Enforcing subsystem boundaries, isolating workspaces, and routing models by task complexity.</a:t>
+              <a:defRPr sz="1700">
+                <a:solidFill>
+                  <a:srgbClr val="94A3B8"/>
+                </a:solidFill>
+                <a:latin typeface="Segoe UI"/>
+              </a:defRPr>
+            </a:pPr>
+            <a:r>
+              <a:t>Structured review findings with documented technical resolutions.</a:t>
             </a:r>
           </a:p>
         </p:txBody>
@@ -6332,8 +5818,8 @@
         </p:nvSpPr>
         <p:spPr>
           <a:xfrm>
-            <a:off x="731520" y="2377440"/>
-            <a:ext cx="10515600" cy="3840480"/>
+            <a:off x="731520" y="2468880"/>
+            <a:ext cx="10515600" cy="3931920"/>
           </a:xfrm>
           <a:prstGeom prst="rect">
             <a:avLst/>
@@ -6348,65 +5834,65 @@
           <a:p>
             <a:pPr>
               <a:spcAft>
-                <a:spcPts val="1600"/>
+                <a:spcPts val="2000"/>
               </a:spcAft>
-              <a:defRPr sz="1600">
-                <a:solidFill>
-                  <a:srgbClr val="E6EBF2"/>
-                </a:solidFill>
-                <a:latin typeface="Segoe UI"/>
-              </a:defRPr>
-            </a:pPr>
-            <a:r>
-              <a:t>• Bounded Area Scoping: Tracks declare Area (e.g. Area: modern_api vs Area: legacy_adapter).</a:t>
+              <a:defRPr sz="1800">
+                <a:solidFill>
+                  <a:srgbClr val="F1F5F9"/>
+                </a:solidFill>
+                <a:latin typeface="Segoe UI"/>
+              </a:defRPr>
+            </a:pPr>
+            <a:r>
+              <a:t>•  Independent Evaluator: Dedicated code-reviewer agent inspects diff against rules and test coverage.</a:t>
             </a:r>
           </a:p>
           <a:p>
             <a:pPr>
               <a:spcAft>
-                <a:spcPts val="1600"/>
+                <a:spcPts val="2000"/>
               </a:spcAft>
-              <a:defRPr sz="1600">
-                <a:solidFill>
-                  <a:srgbClr val="E6EBF2"/>
-                </a:solidFill>
-                <a:latin typeface="Segoe UI"/>
-              </a:defRPr>
-            </a:pPr>
-            <a:r>
-              <a:t>• Strict Boundary Protection: File edits outside declared track areas are automatically blocked.</a:t>
+              <a:defRPr sz="1800">
+                <a:solidFill>
+                  <a:srgbClr val="F1F5F9"/>
+                </a:solidFill>
+                <a:latin typeface="Segoe UI"/>
+              </a:defRPr>
+            </a:pPr>
+            <a:r>
+              <a:t>•  Durable Ledger: Review findings recorded in .planning/reviews/&lt;bead&gt;/findings.jsonl.</a:t>
             </a:r>
           </a:p>
           <a:p>
             <a:pPr>
               <a:spcAft>
-                <a:spcPts val="1600"/>
+                <a:spcPts val="2000"/>
               </a:spcAft>
-              <a:defRPr sz="1600">
-                <a:solidFill>
-                  <a:srgbClr val="E6EBF2"/>
-                </a:solidFill>
-                <a:latin typeface="Segoe UI"/>
-              </a:defRPr>
-            </a:pPr>
-            <a:r>
-              <a:t>• Git Worktree Isolation: /orchestrate provisions clean worktrees in .planning/worktrees/ for each track.</a:t>
+              <a:defRPr sz="1800">
+                <a:solidFill>
+                  <a:srgbClr val="F1F5F9"/>
+                </a:solidFill>
+                <a:latin typeface="Segoe UI"/>
+              </a:defRPr>
+            </a:pPr>
+            <a:r>
+              <a:t>•  Technical Resolution Protocol: Engineers must verify and record Fix, Dispute, or Defer.</a:t>
             </a:r>
           </a:p>
           <a:p>
             <a:pPr>
               <a:spcAft>
-                <a:spcPts val="1600"/>
+                <a:spcPts val="2000"/>
               </a:spcAft>
-              <a:defRPr sz="1600">
-                <a:solidFill>
-                  <a:srgbClr val="E6EBF2"/>
-                </a:solidFill>
-                <a:latin typeface="Segoe UI"/>
-              </a:defRPr>
-            </a:pPr>
-            <a:r>
-              <a:t>• Complexity-Based Model Routing: Orchestrator evaluates track difficulty to assign optimal reasoning tiers (low/med/high).</a:t>
+              <a:defRPr sz="1800">
+                <a:solidFill>
+                  <a:srgbClr val="F1F5F9"/>
+                </a:solidFill>
+                <a:latin typeface="Segoe UI"/>
+              </a:defRPr>
+            </a:pPr>
+            <a:r>
+              <a:t>•  No Blind Acceptance: No task closes with unresolved or unaddressed review ledger items.</a:t>
             </a:r>
           </a:p>
         </p:txBody>
@@ -6444,7 +5930,7 @@
             <a:avLst/>
           </a:prstGeom>
           <a:solidFill>
-            <a:srgbClr val="0F141B"/>
+            <a:srgbClr val="0B0F15"/>
           </a:solidFill>
           <a:ln>
             <a:noFill/>
@@ -6495,15 +5981,15 @@
           <a:lstStyle/>
           <a:p>
             <a:pPr>
-              <a:defRPr sz="1300" b="1">
-                <a:solidFill>
-                  <a:srgbClr val="7EA2FF"/>
-                </a:solidFill>
-                <a:latin typeface="Segoe UI"/>
-              </a:defRPr>
-            </a:pPr>
-            <a:r>
-              <a:t>STAGE 4: EXECUTE</a:t>
+              <a:defRPr sz="1400" b="1">
+                <a:solidFill>
+                  <a:srgbClr val="60A5FA"/>
+                </a:solidFill>
+                <a:latin typeface="Segoe UI"/>
+              </a:defRPr>
+            </a:pPr>
+            <a:r>
+              <a:t>QUALITY ENGINEERING</a:t>
             </a:r>
           </a:p>
         </p:txBody>
@@ -6531,15 +6017,15 @@
           <a:lstStyle/>
           <a:p>
             <a:pPr>
-              <a:defRPr sz="2600" b="1">
-                <a:solidFill>
-                  <a:srgbClr val="E6EBF2"/>
-                </a:solidFill>
-                <a:latin typeface="Segoe UI"/>
-              </a:defRPr>
-            </a:pPr>
-            <a:r>
-              <a:t>Ensuring Code Strictly Matches Specification</a:t>
+              <a:defRPr sz="2800" b="1">
+                <a:solidFill>
+                  <a:srgbClr val="F1F5F9"/>
+                </a:solidFill>
+                <a:latin typeface="Segoe UI"/>
+              </a:defRPr>
+            </a:pPr>
+            <a:r>
+              <a:t>Focused QA: Preventing Test Overwhelm with gin-qa</a:t>
             </a:r>
           </a:p>
         </p:txBody>
@@ -6552,8 +6038,8 @@
         </p:nvSpPr>
         <p:spPr>
           <a:xfrm>
-            <a:off x="731520" y="1645920"/>
-            <a:ext cx="10515600" cy="457200"/>
+            <a:off x="731520" y="1691640"/>
+            <a:ext cx="10515600" cy="502920"/>
           </a:xfrm>
           <a:prstGeom prst="rect">
             <a:avLst/>
@@ -6567,15 +6053,15 @@
           <a:lstStyle/>
           <a:p>
             <a:pPr>
-              <a:defRPr sz="1500">
-                <a:solidFill>
-                  <a:srgbClr val="9AA6B6"/>
-                </a:solidFill>
-                <a:latin typeface="Segoe UI"/>
-              </a:defRPr>
-            </a:pPr>
-            <a:r>
-              <a:t>Guaranteed compliance through bidirectional requirement tagging and automated trace audits.</a:t>
+              <a:defRPr sz="1700">
+                <a:solidFill>
+                  <a:srgbClr val="94A3B8"/>
+                </a:solidFill>
+                <a:latin typeface="Segoe UI"/>
+              </a:defRPr>
+            </a:pPr>
+            <a:r>
+              <a:t>Content-hash drift detection and targeted Playwright E2E automation.</a:t>
             </a:r>
           </a:p>
         </p:txBody>
@@ -6588,8 +6074,8 @@
         </p:nvSpPr>
         <p:spPr>
           <a:xfrm>
-            <a:off x="731520" y="2377440"/>
-            <a:ext cx="10515600" cy="3840480"/>
+            <a:off x="731520" y="2468880"/>
+            <a:ext cx="10515600" cy="3931920"/>
           </a:xfrm>
           <a:prstGeom prst="rect">
             <a:avLst/>
@@ -6604,65 +6090,65 @@
           <a:p>
             <a:pPr>
               <a:spcAft>
-                <a:spcPts val="1600"/>
+                <a:spcPts val="2000"/>
               </a:spcAft>
-              <a:defRPr sz="1600">
-                <a:solidFill>
-                  <a:srgbClr val="E6EBF2"/>
-                </a:solidFill>
-                <a:latin typeface="Segoe UI"/>
-              </a:defRPr>
-            </a:pPr>
-            <a:r>
-              <a:t>• Bidirectional Linkage: Living Spec REQ-ID -&gt; plan.md Track -&gt; Test # REQ-ID -&gt; Implementation.</a:t>
+              <a:defRPr sz="1800">
+                <a:solidFill>
+                  <a:srgbClr val="F1F5F9"/>
+                </a:solidFill>
+                <a:latin typeface="Segoe UI"/>
+              </a:defRPr>
+            </a:pPr>
+            <a:r>
+              <a:t>•  The Overwhelm Trap: Unconstrained AI generates hundreds of low-value, noisy test cases.</a:t>
             </a:r>
           </a:p>
           <a:p>
             <a:pPr>
               <a:spcAft>
-                <a:spcPts val="1600"/>
+                <a:spcPts val="2000"/>
               </a:spcAft>
-              <a:defRPr sz="1600">
-                <a:solidFill>
-                  <a:srgbClr val="E6EBF2"/>
-                </a:solidFill>
-                <a:latin typeface="Segoe UI"/>
-              </a:defRPr>
-            </a:pPr>
-            <a:r>
-              <a:t>• Test-Driven Development: Failing unit/integration tests must precede implementation code.</a:t>
+              <a:defRPr sz="1800">
+                <a:solidFill>
+                  <a:srgbClr val="F1F5F9"/>
+                </a:solidFill>
+                <a:latin typeface="Segoe UI"/>
+              </a:defRPr>
+            </a:pPr>
+            <a:r>
+              <a:t>•  Policy Steering (qa/guidelines.md): QA reserves E2E tests for critical user paths, offloading edge cases.</a:t>
             </a:r>
           </a:p>
           <a:p>
             <a:pPr>
               <a:spcAft>
-                <a:spcPts val="1600"/>
+                <a:spcPts val="2000"/>
               </a:spcAft>
-              <a:defRPr sz="1600">
-                <a:solidFill>
-                  <a:srgbClr val="E6EBF2"/>
-                </a:solidFill>
-                <a:latin typeface="Segoe UI"/>
-              </a:defRPr>
-            </a:pPr>
-            <a:r>
-              <a:t>• Automated Audit (specs trace): Audits codebase to ensure 100% of requirement scenarios have tests.</a:t>
+              <a:defRPr sz="1800">
+                <a:solidFill>
+                  <a:srgbClr val="F1F5F9"/>
+                </a:solidFill>
+                <a:latin typeface="Segoe UI"/>
+              </a:defRPr>
+            </a:pPr>
+            <a:r>
+              <a:t>•  Hash-Pinned Drift Detection: Tests store SHA hashes (REQ-ID@hash); reports only missing or stale cases.</a:t>
             </a:r>
           </a:p>
           <a:p>
             <a:pPr>
               <a:spcAft>
-                <a:spcPts val="1600"/>
+                <a:spcPts val="2000"/>
               </a:spcAft>
-              <a:defRPr sz="1600">
-                <a:solidFill>
-                  <a:srgbClr val="E6EBF2"/>
-                </a:solidFill>
-                <a:latin typeface="Segoe UI"/>
-              </a:defRPr>
-            </a:pPr>
-            <a:r>
-              <a:t>• Zero Tolerance: Missing requirement tests block the verification and ship gates.</a:t>
+              <a:defRPr sz="1800">
+                <a:solidFill>
+                  <a:srgbClr val="F1F5F9"/>
+                </a:solidFill>
+                <a:latin typeface="Segoe UI"/>
+              </a:defRPr>
+            </a:pPr>
+            <a:r>
+              <a:t>•  Zero Duplicate Work: Existing valid tests are untouched; QA focuses only on modified requirement deltas.</a:t>
             </a:r>
           </a:p>
         </p:txBody>

</xml_diff>